<commit_message>
Perbarui semua dokumen dengan eksperimen latih di data asli
- Laporan UAS: subbab 4.5 baru (tabel, grafik, pembahasan), skenario
  evaluasi, ringkasan data, kesimpulan dan saran
- Proposal UTS: sumber data, skenario evaluasi, hasil awal
- Slide UAS: slide baru "Latih & uji hanya dengan data asli" (22 slide)
- Slide UTS: slide data, skenario evaluasi (4 langkah), hasil awal
- LAPORAN.md, README, dan panduan pengumpulan disesuaikan
</commit_message>
<xml_diff>
--- a/docs/tugas/UAS_Slide_Kelompok6_A11.4502.pptx
+++ b/docs/tugas/UAS_Slide_Kelompok6_A11.4502.pptx
@@ -26,9 +26,10 @@
     <p:sldId id="274" r:id="rId20"/>
     <p:sldId id="275" r:id="rId21"/>
     <p:sldId id="276" r:id="rId22"/>
+    <p:sldId id="277" r:id="rId23"/>
   </p:sldIdLst>
   <p:notesMasterIdLst>
-    <p:notesMasterId r:id="rId23"/>
+    <p:notesMasterId r:id="rId24"/>
   </p:notesMasterIdLst>
   <p:sldSz cx="12192000" cy="6858000"/>
   <p:notesSz cx="6858000" cy="12192000"/>
@@ -563,6 +564,311 @@
 </c:chartSpace>
 </file>
 
+<file path=ppt/charts/chart2.xml><?xml version="1.0" encoding="utf-8"?>
+<c:chartSpace xmlns:c="http://schemas.openxmlformats.org/drawingml/2006/chart" xmlns:a="http://schemas.openxmlformats.org/drawingml/2006/main" xmlns:r="http://schemas.openxmlformats.org/officeDocument/2006/relationships">
+  <c:date1904 val="0"/>
+  <c:roundedCorners val="1"/>
+  <c:chart>
+    <c:title>
+      <c:tx>
+        <c:rich>
+          <a:bodyPr/>
+          <a:lstStyle/>
+          <a:p>
+            <a:pPr>
+              <a:defRPr sz="1400" b="0" i="0" u="none" strike="noStrike">
+                <a:solidFill>
+                  <a:srgbClr val="E6EDF3"/>
+                </a:solidFill>
+                <a:latin typeface="Arial"/>
+              </a:defRPr>
+            </a:pPr>
+            <a:r>
+              <a:rPr sz="1400" b="0" i="0" u="none" strike="noStrike">
+                <a:solidFill>
+                  <a:srgbClr val="E6EDF3"/>
+                </a:solidFill>
+                <a:latin typeface="Arial"/>
+              </a:rPr>
+              <a:t>Accuracy (%) — 1.192 baris data asli, 5-fold per siklus pity</a:t>
+            </a:r>
+          </a:p>
+        </c:rich>
+      </c:tx>
+      <c:layout/>
+      <c:overlay val="0"/>
+    </c:title>
+    <c:autoTitleDeleted val="0"/>
+    <c:plotArea>
+      <c:layout/>
+      <c:barChart>
+        <c:barDir val="col"/>
+        <c:grouping val="clustered"/>
+        <c:varyColors val="0"/>
+        <c:ser>
+          <c:idx val="0"/>
+          <c:order val="0"/>
+          <c:tx>
+            <c:strRef>
+              <c:f>Sheet1!$B$1</c:f>
+              <c:strCache>
+                <c:ptCount val="1"/>
+                <c:pt idx="0">
+                  <c:v>Accuracy (%)</c:v>
+                </c:pt>
+              </c:strCache>
+            </c:strRef>
+          </c:tx>
+          <c:spPr>
+            <a:solidFill>
+              <a:srgbClr val="3FB950"/>
+            </a:solidFill>
+            <a:effectLst/>
+          </c:spPr>
+          <c:invertIfNegative val="0"/>
+          <c:dLbls>
+            <c:numFmt formatCode="0.0" sourceLinked="0"/>
+            <c:txPr>
+              <a:bodyPr/>
+              <a:lstStyle/>
+              <a:p>
+                <a:pPr>
+                  <a:defRPr b="0" i="0" strike="noStrike" sz="900" u="none">
+                    <a:solidFill>
+                      <a:srgbClr val="E6EDF3"/>
+                    </a:solidFill>
+                    <a:latin typeface="Arial"/>
+                  </a:defRPr>
+                </a:pPr>
+              </a:p>
+            </c:txPr>
+            <c:showLegendKey val="0"/>
+            <c:showVal val="1"/>
+            <c:showCatName val="0"/>
+            <c:showSerName val="0"/>
+            <c:showPercent val="0"/>
+            <c:showBubbleSize val="0"/>
+            <c:showLeaderLines val="0"/>
+          </c:dLbls>
+          <c:cat>
+            <c:multiLvlStrRef>
+              <c:f>Sheet1!$A$2:$A$9</c:f>
+              <c:multiLvlStrCache>
+                <c:ptCount val="8"/>
+                <c:lvl>
+                  <c:pt idx="0">
+                    <c:v>Baseline</c:v>
+                  </c:pt>
+                  <c:pt idx="1">
+                    <c:v>Markov (teori)</c:v>
+                  </c:pt>
+                  <c:pt idx="2">
+                    <c:v>Naive Bayes</c:v>
+                  </c:pt>
+                  <c:pt idx="3">
+                    <c:v>KNN</c:v>
+                  </c:pt>
+                  <c:pt idx="4">
+                    <c:v>Log. Regression</c:v>
+                  </c:pt>
+                  <c:pt idx="5">
+                    <c:v>Decision Tree</c:v>
+                  </c:pt>
+                  <c:pt idx="6">
+                    <c:v>Random Forest</c:v>
+                  </c:pt>
+                  <c:pt idx="7">
+                    <c:v>XGBoost</c:v>
+                  </c:pt>
+                </c:lvl>
+              </c:multiLvlStrCache>
+            </c:multiLvlStrRef>
+          </c:cat>
+          <c:val>
+            <c:numRef>
+              <c:f>Sheet1!$B$2:$B$9</c:f>
+              <c:numCache>
+                <c:formatCode>General</c:formatCode>
+                <c:ptCount val="8"/>
+                <c:pt idx="0">
+                  <c:v>86.4</c:v>
+                </c:pt>
+                <c:pt idx="1">
+                  <c:v>93.6</c:v>
+                </c:pt>
+                <c:pt idx="2">
+                  <c:v>88</c:v>
+                </c:pt>
+                <c:pt idx="3">
+                  <c:v>87.4</c:v>
+                </c:pt>
+                <c:pt idx="4">
+                  <c:v>91</c:v>
+                </c:pt>
+                <c:pt idx="5">
+                  <c:v>93</c:v>
+                </c:pt>
+                <c:pt idx="6">
+                  <c:v>92.9</c:v>
+                </c:pt>
+                <c:pt idx="7">
+                  <c:v>92.6</c:v>
+                </c:pt>
+              </c:numCache>
+            </c:numRef>
+          </c:val>
+        </c:ser>
+        <c:dLbls>
+          <c:numFmt formatCode="0.0" sourceLinked="0"/>
+          <c:txPr>
+            <a:bodyPr/>
+            <a:lstStyle/>
+            <a:p>
+              <a:pPr>
+                <a:defRPr b="0" i="0" strike="noStrike" sz="900" u="none">
+                  <a:solidFill>
+                    <a:srgbClr val="E6EDF3"/>
+                  </a:solidFill>
+                  <a:latin typeface="Arial"/>
+                </a:defRPr>
+              </a:pPr>
+            </a:p>
+          </c:txPr>
+          <c:showLegendKey val="0"/>
+          <c:showVal val="1"/>
+          <c:showCatName val="0"/>
+          <c:showSerName val="0"/>
+          <c:showPercent val="0"/>
+          <c:showBubbleSize val="0"/>
+          <c:showLeaderLines val="0"/>
+        </c:dLbls>
+        <c:gapWidth val="150"/>
+        <c:overlap val="0"/>
+        <c:axId val="2094734554"/>
+        <c:axId val="2094734552"/>
+        <c:axId val="2094734556"/>
+      </c:barChart>
+      <c:catAx>
+        <c:axId val="2094734554"/>
+        <c:scaling>
+          <c:orientation val="minMax"/>
+        </c:scaling>
+        <c:delete val="0"/>
+        <c:axPos val="b"/>
+        <c:numFmt formatCode="General" sourceLinked="1"/>
+        <c:majorTickMark val="out"/>
+        <c:minorTickMark val="none"/>
+        <c:tickLblPos val="low"/>
+        <c:spPr>
+          <a:ln w="12700" cap="flat">
+            <a:solidFill>
+              <a:srgbClr val="888888"/>
+            </a:solidFill>
+            <a:prstDash val="solid"/>
+            <a:round/>
+          </a:ln>
+        </c:spPr>
+        <c:txPr>
+          <a:bodyPr/>
+          <a:lstStyle/>
+          <a:p>
+            <a:pPr>
+              <a:defRPr sz="1000" b="0" i="0" u="none" strike="noStrike">
+                <a:solidFill>
+                  <a:srgbClr val="A9B4C2"/>
+                </a:solidFill>
+                <a:latin typeface="Arial"/>
+              </a:defRPr>
+            </a:pPr>
+            <a:endParaRPr lang="en-US"/>
+          </a:p>
+        </c:txPr>
+        <c:crossAx val="2094734552"/>
+        <c:crosses val="autoZero"/>
+        <c:auto val="1"/>
+        <c:lblAlgn val="ctr"/>
+        <c:noMultiLvlLbl val="1"/>
+      </c:catAx>
+      <c:valAx>
+        <c:axId val="2094734552"/>
+        <c:scaling>
+          <c:orientation val="minMax"/>
+          <c:max val="96"/>
+          <c:min val="80"/>
+        </c:scaling>
+        <c:delete val="0"/>
+        <c:axPos val="l"/>
+        <c:majorGridlines>
+          <c:spPr>
+            <a:ln w="6350" cap="flat">
+              <a:solidFill>
+                <a:srgbClr val="30363D"/>
+              </a:solidFill>
+              <a:prstDash val="solid"/>
+              <a:round/>
+            </a:ln>
+          </c:spPr>
+        </c:majorGridlines>
+        <c:numFmt formatCode="General" sourceLinked="0"/>
+        <c:majorTickMark val="out"/>
+        <c:minorTickMark val="none"/>
+        <c:tickLblPos val="nextTo"/>
+        <c:spPr>
+          <a:ln w="12700" cap="flat">
+            <a:solidFill>
+              <a:srgbClr val="888888"/>
+            </a:solidFill>
+            <a:prstDash val="solid"/>
+            <a:round/>
+          </a:ln>
+        </c:spPr>
+        <c:txPr>
+          <a:bodyPr/>
+          <a:lstStyle/>
+          <a:p>
+            <a:pPr>
+              <a:defRPr sz="1000" b="0" i="0" u="none" strike="noStrike">
+                <a:solidFill>
+                  <a:srgbClr val="A9B4C2"/>
+                </a:solidFill>
+                <a:latin typeface="Arial"/>
+              </a:defRPr>
+            </a:pPr>
+            <a:endParaRPr lang="en-US"/>
+          </a:p>
+        </c:txPr>
+        <c:crossAx val="2094734554"/>
+        <c:crosses val="autoZero"/>
+        <c:crossBetween val="between"/>
+      </c:valAx>
+      <c:spPr>
+        <a:solidFill>
+          <a:srgbClr val="0E1117"/>
+        </a:solidFill>
+        <a:ln>
+          <a:noFill/>
+        </a:ln>
+        <a:effectLst/>
+      </c:spPr>
+    </c:plotArea>
+    <c:plotVisOnly val="1"/>
+    <c:dispBlanksAs val="span"/>
+  </c:chart>
+  <c:spPr>
+    <a:solidFill>
+      <a:srgbClr val="0E1117"/>
+    </a:solidFill>
+    <a:ln>
+      <a:noFill/>
+    </a:ln>
+    <a:effectLst/>
+  </c:spPr>
+  <c:externalData r:id="rId1">
+    <c:autoUpdate val="0"/>
+  </c:externalData>
+</c:chartSpace>
+</file>
+
 <file path=ppt/notesMasters/notesMaster1.xml><?xml version="1.0" encoding="utf-8"?>
 <p:notesMaster xmlns:a="http://schemas.openxmlformats.org/drawingml/2006/main" xmlns:r="http://schemas.openxmlformats.org/officeDocument/2006/relationships" xmlns:p="http://schemas.openxmlformats.org/presentationml/2006/main">
   <p:cSld>
@@ -1046,7 +1352,7 @@
           <a:p>
             <a:r>
               <a:rPr lang="en-US" dirty="0"/>
-              <a:t>Data (±1,5 menit). Riwayat satu akun terlalu sedikit untuk melatih model, jadi data latih memakai simulasi Monte Carlo dari model Markov, 400 akun. Data asli dua akun dipakai khusus untuk menguji. Jelaskan cara pengambilan data asli lewat script PowerShell yang hanya membaca cache game, dan bahwa authkey tidak disimpan.</a:t>
+              <a:t>Data (±1,5 menit). Riwayat satu akun terlalu sedikit untuk melatih model, jadi data latih memakai simulasi Monte Carlo dari model Markov, 400 akun. Data asli dua akun, 1.424 baris, sudah memenuhi syarat dataset tabel minimal 500 sampai 1000 baris. Data asli dipakai untuk menguji, dan di eksperimen kedua keenam algoritma juga dilatih dan diuji hanya dengan data asli. Jelaskan cara pengambilan data asli lewat script PowerShell yang hanya membaca cache game, dan bahwa authkey tidak disimpan.</a:t>
             </a:r>
             <a:endParaRPr lang="en-US" dirty="0"/>
           </a:p>
@@ -1750,7 +2056,7 @@
           <a:p>
             <a:r>
               <a:rPr lang="en-US" dirty="0"/>
-              <a:t>Kurva peluang (±2 menit). Jelaskan grafik: sumbu x pity saat ini, sumbu y peluang dapat S dalam 10 pull. Model pohon dan KNN mengikuti garis teori, termasuk lonjakan tajam. Logistic Regression dan Naive Bayes tidak mampu karena bentuk modelnya halus. Decision Tree menemukan titik soft pity sendiri dari data.</a:t>
+              <a:t>Eksperimen kedua (±2 menit). Untuk menjawab apakah model hanya bagus di data simulasi, kami melatih dan menguji keenam algoritma hanya dengan data asli: 1.192 baris dari 2 akun, sudah di atas syarat 500 sampai 1000 baris. Data dibagi per siklus pity menjadi 5 bagian. Hasilnya: Decision Tree 93,0 persen, Random Forest 92,9 persen, XGBoost 92,6 persen, urutannya sama seperti di simulasi dan hampir menyamai batas teori Markov 93,6 persen. Logistic Regression 91,0 persen dan Naive Bayes 88,0 persen. KNN turun ke 87,4 persen karena nilai k = 101 terlalu besar untuk data sekecil ini, jadi KNN hampir selalu menebak kelas mayoritas. Pelajarannya: hyperparameter harus disesuaikan dengan ukuran data.</a:t>
             </a:r>
             <a:endParaRPr lang="en-US" dirty="0"/>
           </a:p>
@@ -1838,7 +2144,7 @@
           <a:p>
             <a:r>
               <a:rPr lang="en-US" dirty="0"/>
-              <a:t>Confusion matrix dan fitur (±1,5 menit). Baseline tidak pernah menebak dapat S. Feature importance: pity_ratio paling penting, guaranteed hampir nol. Ini sesuai aturan game, jadi model belajar hal yang benar.</a:t>
+              <a:t>Kurva peluang (±2 menit). Jelaskan grafik: sumbu x pity saat ini, sumbu y peluang dapat S dalam 10 pull. Model pohon dan KNN mengikuti garis teori, termasuk lonjakan tajam. Logistic Regression dan Naive Bayes tidak mampu karena bentuk modelnya halus. Decision Tree menemukan titik soft pity sendiri dari data.</a:t>
             </a:r>
             <a:endParaRPr lang="en-US" dirty="0"/>
           </a:p>
@@ -2014,7 +2320,7 @@
           <a:p>
             <a:r>
               <a:rPr lang="en-US" dirty="0"/>
-              <a:t>Kesimpulan (±1,5 menit). Bacakan tiga kesimpulan dan saran pengembangan. Sebutkan keterbatasan: soft pity masih estimasi dan data asli baru dua akun.</a:t>
+              <a:t>Confusion matrix dan fitur (±1,5 menit). Baseline tidak pernah menebak dapat S. Feature importance: pity_ratio paling penting, guaranteed hampir nol. Ini sesuai aturan game, jadi model belajar hal yang benar.</a:t>
             </a:r>
             <a:endParaRPr lang="en-US" dirty="0"/>
           </a:p>
@@ -2102,7 +2408,7 @@
           <a:p>
             <a:r>
               <a:rPr lang="en-US" dirty="0"/>
-              <a:t>Penutup (±1 menit). Ucapkan terima kasih, ajak membuka aplikasi, buka sesi tanya jawab.</a:t>
+              <a:t>Kesimpulan (±1,5 menit). Bacakan tiga kesimpulan dan saran pengembangan. Tekankan bahwa model pohon tetap terbaik walaupun dilatih hanya dengan data asli. Sebutkan keterbatasan: soft pity masih estimasi dan data asli baru dua akun.</a:t>
             </a:r>
             <a:endParaRPr lang="en-US" dirty="0"/>
           </a:p>
@@ -2126,6 +2432,94 @@
             <a:fld id="{F7021451-1387-4CA6-816F-3879F97B5CBC}" type="slidenum">
               <a:rPr lang="en-US"/>
               <a:t>21</a:t>
+            </a:fld>
+            <a:endParaRPr lang="en-US"/>
+          </a:p>
+        </p:txBody>
+      </p:sp>
+    </p:spTree>
+    <p:extLst>
+      <p:ext uri="{BB962C8B-B14F-4D97-AF65-F5344CB8AC3E}">
+        <p14:creationId xmlns:p14="http://schemas.microsoft.com/office/powerpoint/2010/main" val="1024086991"/>
+      </p:ext>
+    </p:extLst>
+  </p:cSld>
+  <p:clrMapOvr>
+    <a:masterClrMapping/>
+  </p:clrMapOvr>
+</p:notes>
+</file>
+
+<file path=ppt/notesSlides/notesSlide22.xml><?xml version="1.0" encoding="utf-8"?>
+<p:notes xmlns:a="http://schemas.openxmlformats.org/drawingml/2006/main" xmlns:r="http://schemas.openxmlformats.org/officeDocument/2006/relationships" xmlns:p="http://schemas.openxmlformats.org/presentationml/2006/main">
+  <p:cSld>
+    <p:spTree>
+      <p:nvGrpSpPr>
+        <p:cNvPr id="1" name=""/>
+        <p:cNvGrpSpPr/>
+        <p:nvPr/>
+      </p:nvGrpSpPr>
+      <p:grpSpPr>
+        <a:xfrm>
+          <a:off x="0" y="0"/>
+          <a:ext cx="0" cy="0"/>
+          <a:chOff x="0" y="0"/>
+          <a:chExt cx="0" cy="0"/>
+        </a:xfrm>
+      </p:grpSpPr>
+      <p:sp>
+        <p:nvSpPr>
+          <p:cNvPr id="2" name="Slide Image Placeholder 1"/>
+          <p:cNvSpPr>
+            <a:spLocks noGrp="1" noRot="1" noChangeAspect="1"/>
+          </p:cNvSpPr>
+          <p:nvPr>
+            <p:ph type="sldImg"/>
+          </p:nvPr>
+        </p:nvSpPr>
+        <p:spPr/>
+      </p:sp>
+      <p:sp>
+        <p:nvSpPr>
+          <p:cNvPr id="3" name="Notes Placeholder 2"/>
+          <p:cNvSpPr>
+            <a:spLocks noGrp="1"/>
+          </p:cNvSpPr>
+          <p:nvPr>
+            <p:ph type="body" idx="1"/>
+          </p:nvPr>
+        </p:nvSpPr>
+        <p:spPr/>
+        <p:txBody>
+          <a:bodyPr/>
+          <a:lstStyle/>
+          <a:p>
+            <a:r>
+              <a:rPr lang="en-US" dirty="0"/>
+              <a:t>Penutup (±1 menit). Ucapkan terima kasih, ajak membuka aplikasi, buka sesi tanya jawab.</a:t>
+            </a:r>
+            <a:endParaRPr lang="en-US" dirty="0"/>
+          </a:p>
+        </p:txBody>
+      </p:sp>
+      <p:sp>
+        <p:nvSpPr>
+          <p:cNvPr id="4" name="Slide Number Placeholder 3"/>
+          <p:cNvSpPr>
+            <a:spLocks noGrp="1"/>
+          </p:cNvSpPr>
+          <p:nvPr>
+            <p:ph type="sldNum" sz="quarter" idx="10"/>
+          </p:nvPr>
+        </p:nvSpPr>
+        <p:spPr/>
+        <p:txBody>
+          <a:bodyPr/>
+          <a:lstStyle/>
+          <a:p>
+            <a:fld id="{F7021451-1387-4CA6-816F-3879F97B5CBC}" type="slidenum">
+              <a:rPr lang="en-US"/>
+              <a:t>22</a:t>
             </a:fld>
             <a:endParaRPr lang="en-US"/>
           </a:p>
@@ -3844,7 +4238,7 @@
                 <a:ea typeface="Calibri" pitchFamily="34" charset="-122"/>
                 <a:cs typeface="Calibri" pitchFamily="34" charset="-120"/>
               </a:rPr>
-              <a:t>1.424 pull · 21 S-Rank · anonim (tanpa UID, nama item, waktu). Hanya untuk menguji, tidak untuk melatih.</a:t>
+              <a:t>1.424 pull · 21 S-Rank · anonim. Dipakai untuk menguji model, dan dalam eksperimen kedua untuk melatih + menguji sendiri (1.192 baris).</a:t>
             </a:r>
             <a:endParaRPr lang="en-US" sz="1600" dirty="0"/>
           </a:p>
@@ -13239,7 +13633,7 @@
                 <a:ea typeface="Calibri" pitchFamily="34" charset="-122"/>
                 <a:cs typeface="Calibri" pitchFamily="34" charset="-120"/>
               </a:rPr>
-              <a:t>PEMBAHASAN</a:t>
+              <a:t>HASIL · EKSPERIMEN KEDUA</a:t>
             </a:r>
             <a:endParaRPr lang="en-US" sz="1200" dirty="0"/>
           </a:p>
@@ -13278,7 +13672,7 @@
                 <a:ea typeface="Cambria" pitchFamily="34" charset="-122"/>
                 <a:cs typeface="Cambria" pitchFamily="34" charset="-120"/>
               </a:rPr>
-              <a:t>Model pohon menemukan soft pity sendiri</a:t>
+              <a:t>Latih &amp; uji hanya dengan data asli</a:t>
             </a:r>
             <a:endParaRPr lang="en-US" sz="3200" dirty="0"/>
           </a:p>
@@ -13362,156 +13756,36 @@
           </a:p>
         </p:txBody>
       </p:sp>
-      <p:sp>
-        <p:nvSpPr>
-          <p:cNvPr id="6" name="Shape 4"/>
+      <p:graphicFrame>
+        <p:nvGraphicFramePr>
+          <p:cNvPr id="6" name="Chart 0" descr=""/>
+          <p:cNvGraphicFramePr/>
+          <p:nvPr/>
+        </p:nvGraphicFramePr>
+        <p:xfrm>
+          <a:off x="548640" y="1554480"/>
+          <a:ext cx="7680960" cy="4663440"/>
+        </p:xfrm>
+        <a:graphic xmlns:a="http://schemas.openxmlformats.org/drawingml/2006/main">
+          <a:graphicData uri="http://schemas.openxmlformats.org/drawingml/2006/chart">
+            <c:chart xmlns:c="http://schemas.openxmlformats.org/drawingml/2006/chart" r:id="rId1"/>
+          </a:graphicData>
+        </a:graphic>
+      </p:graphicFrame>
+      <p:sp>
+        <p:nvSpPr>
+          <p:cNvPr id="7" name="Shape 4"/>
           <p:cNvSpPr/>
           <p:nvPr/>
         </p:nvSpPr>
         <p:spPr>
           <a:xfrm>
-            <a:off x="438912" y="1591056"/>
-            <a:ext cx="7717536" cy="3218688"/>
+            <a:off x="8503920" y="1645920"/>
+            <a:ext cx="3108960" cy="2286000"/>
           </a:xfrm>
           <a:prstGeom prst="roundRect">
             <a:avLst>
-              <a:gd name="adj" fmla="val 1705"/>
-            </a:avLst>
-          </a:prstGeom>
-          <a:solidFill>
-            <a:srgbClr val="FFFFFF"/>
-          </a:solidFill>
-          <a:ln w="12700">
-            <a:solidFill>
-              <a:srgbClr val="30363D"/>
-            </a:solidFill>
-            <a:prstDash val="solid"/>
-          </a:ln>
-        </p:spPr>
-      </p:sp>
-      <p:pic>
-        <p:nvPicPr>
-          <p:cNvPr id="7" name="Image 0" descr="fig_kurva.png">    </p:cNvPr>
-          <p:cNvPicPr>
-            <a:picLocks noChangeAspect="1"/>
-          </p:cNvPicPr>
-          <p:nvPr/>
-        </p:nvPicPr>
-        <p:blipFill>
-          <a:blip r:embed="rId1"/>
-          <a:stretch>
-            <a:fillRect/>
-          </a:stretch>
-        </p:blipFill>
-        <p:spPr>
-          <a:xfrm>
-            <a:off x="548640" y="1700784"/>
-            <a:ext cx="7498080" cy="2999232"/>
-          </a:xfrm>
-          <a:prstGeom prst="rect">
-            <a:avLst/>
-          </a:prstGeom>
-        </p:spPr>
-      </p:pic>
-      <p:sp>
-        <p:nvSpPr>
-          <p:cNvPr id="8" name="Text 5"/>
-          <p:cNvSpPr txBox="1"/>
-          <p:nvPr/>
-        </p:nvSpPr>
-        <p:spPr>
-          <a:xfrm>
-            <a:off x="548640" y="5029200"/>
-            <a:ext cx="10972800" cy="1280160"/>
-          </a:xfrm>
-          <a:prstGeom prst="rect">
-            <a:avLst/>
-          </a:prstGeom>
-          <a:noFill/>
-          <a:ln/>
-        </p:spPr>
-        <p:txBody>
-          <a:bodyPr wrap="square" lIns="0" tIns="0" rIns="0" bIns="0" rtlCol="0" anchor="t"/>
-          <a:lstStyle/>
-          <a:p>
-            <a:pPr marL="228600" indent="-228600">
-              <a:spcAft>
-                <a:spcPts val="1000"/>
-              </a:spcAft>
-              <a:buSzPct val="100000"/>
-              <a:buChar char="•"/>
-            </a:pPr>
-            <a:r>
-              <a:rPr lang="en-US" sz="1500" dirty="0">
-                <a:solidFill>
-                  <a:srgbClr val="E6EDF3"/>
-                </a:solidFill>
-                <a:latin typeface="Calibri" pitchFamily="34" charset="0"/>
-                <a:ea typeface="Calibri" pitchFamily="34" charset="-122"/>
-                <a:cs typeface="Calibri" pitchFamily="34" charset="-120"/>
-              </a:rPr>
-              <a:t>Garis putus-putus = peluang teori (Markov)</a:t>
-            </a:r>
-            <a:endParaRPr lang="en-US" sz="1500" dirty="0"/>
-          </a:p>
-          <a:p>
-            <a:pPr marL="228600" indent="-228600">
-              <a:spcAft>
-                <a:spcPts val="1000"/>
-              </a:spcAft>
-              <a:buSzPct val="100000"/>
-              <a:buChar char="•"/>
-            </a:pPr>
-            <a:r>
-              <a:rPr lang="en-US" sz="1500" dirty="0">
-                <a:solidFill>
-                  <a:srgbClr val="E6EDF3"/>
-                </a:solidFill>
-                <a:latin typeface="Calibri" pitchFamily="34" charset="0"/>
-                <a:ea typeface="Calibri" pitchFamily="34" charset="-122"/>
-                <a:cs typeface="Calibri" pitchFamily="34" charset="-120"/>
-              </a:rPr>
-              <a:t>Pohon &amp; KNN menempel ke teori, termasuk lonjakan soft pity</a:t>
-            </a:r>
-            <a:endParaRPr lang="en-US" sz="1500" dirty="0"/>
-          </a:p>
-          <a:p>
-            <a:pPr marL="228600" indent="-228600">
-              <a:spcAft>
-                <a:spcPts val="1000"/>
-              </a:spcAft>
-              <a:buSzPct val="100000"/>
-              <a:buChar char="•"/>
-            </a:pPr>
-            <a:r>
-              <a:rPr lang="en-US" sz="1500" dirty="0">
-                <a:solidFill>
-                  <a:srgbClr val="E6EDF3"/>
-                </a:solidFill>
-                <a:latin typeface="Calibri" pitchFamily="34" charset="0"/>
-                <a:ea typeface="Calibri" pitchFamily="34" charset="-122"/>
-                <a:cs typeface="Calibri" pitchFamily="34" charset="-120"/>
-              </a:rPr>
-              <a:t>Logistic Regression &amp; Naive Bayes hanya kurva halus → meleset</a:t>
-            </a:r>
-            <a:endParaRPr lang="en-US" sz="1500" dirty="0"/>
-          </a:p>
-        </p:txBody>
-      </p:sp>
-      <p:sp>
-        <p:nvSpPr>
-          <p:cNvPr id="9" name="Shape 6"/>
-          <p:cNvSpPr/>
-          <p:nvPr/>
-        </p:nvSpPr>
-        <p:spPr>
-          <a:xfrm>
-            <a:off x="8412480" y="1554480"/>
-            <a:ext cx="3200400" cy="3291840"/>
-          </a:xfrm>
-          <a:prstGeom prst="roundRect">
-            <a:avLst>
-              <a:gd name="adj" fmla="val 2286"/>
+              <a:gd name="adj" fmla="val 3200"/>
             </a:avLst>
           </a:prstGeom>
           <a:solidFill>
@@ -13527,14 +13801,14 @@
       </p:sp>
       <p:sp>
         <p:nvSpPr>
-          <p:cNvPr id="10" name="Text 7"/>
+          <p:cNvPr id="8" name="Text 5"/>
           <p:cNvSpPr txBox="1"/>
           <p:nvPr/>
         </p:nvSpPr>
         <p:spPr>
           <a:xfrm>
-            <a:off x="8641080" y="1783080"/>
-            <a:ext cx="2743200" cy="411480"/>
+            <a:off x="8732520" y="1874520"/>
+            <a:ext cx="2651760" cy="411480"/>
           </a:xfrm>
           <a:prstGeom prst="rect">
             <a:avLst/>
@@ -13558,7 +13832,7 @@
                 <a:ea typeface="Cambria" pitchFamily="34" charset="-122"/>
                 <a:cs typeface="Cambria" pitchFamily="34" charset="-120"/>
               </a:rPr>
-              <a:t>Tanpa diberi tahu</a:t>
+              <a:t>Tetap konsisten</a:t>
             </a:r>
             <a:endParaRPr lang="en-US" sz="1800" dirty="0"/>
           </a:p>
@@ -13566,14 +13840,14 @@
       </p:sp>
       <p:sp>
         <p:nvSpPr>
-          <p:cNvPr id="11" name="Text 8"/>
+          <p:cNvPr id="9" name="Text 6"/>
           <p:cNvSpPr txBox="1"/>
           <p:nvPr/>
         </p:nvSpPr>
         <p:spPr>
           <a:xfrm>
-            <a:off x="8641080" y="2240280"/>
-            <a:ext cx="2743200" cy="2423160"/>
+            <a:off x="8732520" y="2331720"/>
+            <a:ext cx="2651760" cy="1417320"/>
           </a:xfrm>
           <a:prstGeom prst="rect">
             <a:avLst/>
@@ -13592,7 +13866,7 @@
               <a:buNone/>
             </a:pPr>
             <a:r>
-              <a:rPr lang="en-US" sz="1500" dirty="0">
+              <a:rPr lang="en-US" sz="1400" dirty="0">
                 <a:solidFill>
                   <a:srgbClr val="A9B4C2"/>
                 </a:solidFill>
@@ -13600,9 +13874,117 @@
                 <a:ea typeface="Calibri" pitchFamily="34" charset="-122"/>
                 <a:cs typeface="Calibri" pitchFamily="34" charset="-120"/>
               </a:rPr>
-              <a:t>Decision Tree memisahkan data di pity_ratio ±0,72, sekitar 10 pull sebelum soft pity.</a:t>
+              <a:t>Decision Tree 93,0%, Random Forest 92,9%, XGBoost 92,6%: urutan sama seperti di simulasi.</a:t>
             </a:r>
-            <a:endParaRPr lang="en-US" sz="1500" dirty="0"/>
+            <a:endParaRPr lang="en-US" sz="1400" dirty="0"/>
+          </a:p>
+        </p:txBody>
+      </p:sp>
+      <p:sp>
+        <p:nvSpPr>
+          <p:cNvPr id="10" name="Shape 7"/>
+          <p:cNvSpPr/>
+          <p:nvPr/>
+        </p:nvSpPr>
+        <p:spPr>
+          <a:xfrm>
+            <a:off x="8503920" y="4114800"/>
+            <a:ext cx="3108960" cy="2011680"/>
+          </a:xfrm>
+          <a:prstGeom prst="roundRect">
+            <a:avLst>
+              <a:gd name="adj" fmla="val 3636"/>
+            </a:avLst>
+          </a:prstGeom>
+          <a:solidFill>
+            <a:srgbClr val="1C2230"/>
+          </a:solidFill>
+          <a:ln w="9525">
+            <a:solidFill>
+              <a:srgbClr val="30363D"/>
+            </a:solidFill>
+            <a:prstDash val="solid"/>
+          </a:ln>
+        </p:spPr>
+      </p:sp>
+      <p:sp>
+        <p:nvSpPr>
+          <p:cNvPr id="11" name="Text 8"/>
+          <p:cNvSpPr txBox="1"/>
+          <p:nvPr/>
+        </p:nvSpPr>
+        <p:spPr>
+          <a:xfrm>
+            <a:off x="8732520" y="4343400"/>
+            <a:ext cx="2651760" cy="411480"/>
+          </a:xfrm>
+          <a:prstGeom prst="rect">
+            <a:avLst/>
+          </a:prstGeom>
+          <a:noFill/>
+          <a:ln/>
+        </p:spPr>
+        <p:txBody>
+          <a:bodyPr wrap="square" lIns="0" tIns="0" rIns="0" bIns="0" rtlCol="0" anchor="t"/>
+          <a:lstStyle/>
+          <a:p>
+            <a:pPr indent="0" marL="0">
+              <a:buNone/>
+            </a:pPr>
+            <a:r>
+              <a:rPr lang="en-US" sz="1800" b="1" dirty="0">
+                <a:solidFill>
+                  <a:srgbClr val="FF7EB6"/>
+                </a:solidFill>
+                <a:latin typeface="Cambria" pitchFamily="34" charset="0"/>
+                <a:ea typeface="Cambria" pitchFamily="34" charset="-122"/>
+                <a:cs typeface="Cambria" pitchFamily="34" charset="-120"/>
+              </a:rPr>
+              <a:t>KNN turun</a:t>
+            </a:r>
+            <a:endParaRPr lang="en-US" sz="1800" dirty="0"/>
+          </a:p>
+        </p:txBody>
+      </p:sp>
+      <p:sp>
+        <p:nvSpPr>
+          <p:cNvPr id="12" name="Text 9"/>
+          <p:cNvSpPr txBox="1"/>
+          <p:nvPr/>
+        </p:nvSpPr>
+        <p:spPr>
+          <a:xfrm>
+            <a:off x="8732520" y="4800600"/>
+            <a:ext cx="2651760" cy="1143000"/>
+          </a:xfrm>
+          <a:prstGeom prst="rect">
+            <a:avLst/>
+          </a:prstGeom>
+          <a:noFill/>
+          <a:ln/>
+        </p:spPr>
+        <p:txBody>
+          <a:bodyPr wrap="square" lIns="0" tIns="0" rIns="0" bIns="0" rtlCol="0" anchor="t"/>
+          <a:lstStyle/>
+          <a:p>
+            <a:pPr indent="0" marL="0">
+              <a:spcAft>
+                <a:spcPts val="400"/>
+              </a:spcAft>
+              <a:buNone/>
+            </a:pPr>
+            <a:r>
+              <a:rPr lang="en-US" sz="1400" dirty="0">
+                <a:solidFill>
+                  <a:srgbClr val="A9B4C2"/>
+                </a:solidFill>
+                <a:latin typeface="Calibri" pitchFamily="34" charset="0"/>
+                <a:ea typeface="Calibri" pitchFamily="34" charset="-122"/>
+                <a:cs typeface="Calibri" pitchFamily="34" charset="-120"/>
+              </a:rPr>
+              <a:t>k = 101 terlalu besar untuk ±950 baris latih → hampir selalu menebak mayoritas.</a:t>
+            </a:r>
+            <a:endParaRPr lang="en-US" sz="1400" dirty="0"/>
           </a:p>
         </p:txBody>
       </p:sp>
@@ -13710,7 +14092,7 @@
                 <a:ea typeface="Cambria" pitchFamily="34" charset="-122"/>
                 <a:cs typeface="Cambria" pitchFamily="34" charset="-120"/>
               </a:rPr>
-              <a:t>Confusion matrix &amp; feature importance</a:t>
+              <a:t>Model pohon menemukan soft pity sendiri</a:t>
             </a:r>
             <a:endParaRPr lang="en-US" sz="3200" dirty="0"/>
           </a:p>
@@ -13802,12 +14184,12 @@
         </p:nvSpPr>
         <p:spPr>
           <a:xfrm>
-            <a:off x="438912" y="1602694"/>
-            <a:ext cx="6986016" cy="2372452"/>
+            <a:off x="438912" y="1591056"/>
+            <a:ext cx="7717536" cy="3218688"/>
           </a:xfrm>
           <a:prstGeom prst="roundRect">
             <a:avLst>
-              <a:gd name="adj" fmla="val 2313"/>
+              <a:gd name="adj" fmla="val 1705"/>
             </a:avLst>
           </a:prstGeom>
           <a:solidFill>
@@ -13823,7 +14205,7 @@
       </p:sp>
       <p:pic>
         <p:nvPicPr>
-          <p:cNvPr id="7" name="Image 0" descr="fig_cm.png">    </p:cNvPr>
+          <p:cNvPr id="7" name="Image 0" descr="fig_kurva.png">    </p:cNvPr>
           <p:cNvPicPr>
             <a:picLocks noChangeAspect="1"/>
           </p:cNvPicPr>
@@ -13837,8 +14219,8 @@
         </p:blipFill>
         <p:spPr>
           <a:xfrm>
-            <a:off x="548640" y="1712422"/>
-            <a:ext cx="6766560" cy="2152996"/>
+            <a:off x="548640" y="1700784"/>
+            <a:ext cx="7498080" cy="2999232"/>
           </a:xfrm>
           <a:prstGeom prst="rect">
             <a:avLst/>
@@ -13847,65 +14229,14 @@
       </p:pic>
       <p:sp>
         <p:nvSpPr>
-          <p:cNvPr id="8" name="Shape 5"/>
-          <p:cNvSpPr/>
-          <p:nvPr/>
-        </p:nvSpPr>
-        <p:spPr>
-          <a:xfrm>
-            <a:off x="7479792" y="1824228"/>
-            <a:ext cx="4242816" cy="1929384"/>
-          </a:xfrm>
-          <a:prstGeom prst="roundRect">
-            <a:avLst>
-              <a:gd name="adj" fmla="val 2844"/>
-            </a:avLst>
-          </a:prstGeom>
-          <a:solidFill>
-            <a:srgbClr val="FFFFFF"/>
-          </a:solidFill>
-          <a:ln w="12700">
-            <a:solidFill>
-              <a:srgbClr val="30363D"/>
-            </a:solidFill>
-            <a:prstDash val="solid"/>
-          </a:ln>
-        </p:spPr>
-      </p:sp>
-      <p:pic>
-        <p:nvPicPr>
-          <p:cNvPr id="9" name="Image 1" descr="fig_importance.png">    </p:cNvPr>
-          <p:cNvPicPr>
-            <a:picLocks noChangeAspect="1"/>
-          </p:cNvPicPr>
-          <p:nvPr/>
-        </p:nvPicPr>
-        <p:blipFill>
-          <a:blip r:embed="rId2"/>
-          <a:stretch>
-            <a:fillRect/>
-          </a:stretch>
-        </p:blipFill>
-        <p:spPr>
-          <a:xfrm>
-            <a:off x="7589520" y="1933956"/>
-            <a:ext cx="4023360" cy="1709928"/>
-          </a:xfrm>
-          <a:prstGeom prst="rect">
-            <a:avLst/>
-          </a:prstGeom>
-        </p:spPr>
-      </p:pic>
-      <p:sp>
-        <p:nvSpPr>
-          <p:cNvPr id="10" name="Text 6"/>
+          <p:cNvPr id="8" name="Text 5"/>
           <p:cNvSpPr txBox="1"/>
           <p:nvPr/>
         </p:nvSpPr>
         <p:spPr>
           <a:xfrm>
-            <a:off x="548640" y="4389120"/>
-            <a:ext cx="10972800" cy="1828800"/>
+            <a:off x="548640" y="5029200"/>
+            <a:ext cx="10972800" cy="1280160"/>
           </a:xfrm>
           <a:prstGeom prst="rect">
             <a:avLst/>
@@ -13933,7 +14264,7 @@
                 <a:ea typeface="Calibri" pitchFamily="34" charset="-122"/>
                 <a:cs typeface="Calibri" pitchFamily="34" charset="-120"/>
               </a:rPr>
-              <a:t>Baseline tidak pernah menebak "dapat S" → recall 0</a:t>
+              <a:t>Garis putus-putus = peluang teori (Markov)</a:t>
             </a:r>
             <a:endParaRPr lang="en-US" sz="1500" dirty="0"/>
           </a:p>
@@ -13954,7 +14285,7 @@
                 <a:ea typeface="Calibri" pitchFamily="34" charset="-122"/>
                 <a:cs typeface="Calibri" pitchFamily="34" charset="-120"/>
               </a:rPr>
-              <a:t>XGBoost menangkap sebagian besar S di sekitar soft pity</a:t>
+              <a:t>Pohon &amp; KNN menempel ke teori, termasuk lonjakan soft pity</a:t>
             </a:r>
             <a:endParaRPr lang="en-US" sz="1500" dirty="0"/>
           </a:p>
@@ -13975,7 +14306,115 @@
                 <a:ea typeface="Calibri" pitchFamily="34" charset="-122"/>
                 <a:cs typeface="Calibri" pitchFamily="34" charset="-120"/>
               </a:rPr>
-              <a:t>pity_ratio paling penting; guaranteed ≈ 0 (benar menurut aturan game: guaranteed hanya menentukan S mana, bukan kapan)</a:t>
+              <a:t>Logistic Regression &amp; Naive Bayes hanya kurva halus → meleset</a:t>
+            </a:r>
+            <a:endParaRPr lang="en-US" sz="1500" dirty="0"/>
+          </a:p>
+        </p:txBody>
+      </p:sp>
+      <p:sp>
+        <p:nvSpPr>
+          <p:cNvPr id="9" name="Shape 6"/>
+          <p:cNvSpPr/>
+          <p:nvPr/>
+        </p:nvSpPr>
+        <p:spPr>
+          <a:xfrm>
+            <a:off x="8412480" y="1554480"/>
+            <a:ext cx="3200400" cy="3291840"/>
+          </a:xfrm>
+          <a:prstGeom prst="roundRect">
+            <a:avLst>
+              <a:gd name="adj" fmla="val 2286"/>
+            </a:avLst>
+          </a:prstGeom>
+          <a:solidFill>
+            <a:srgbClr val="1C2230"/>
+          </a:solidFill>
+          <a:ln w="9525">
+            <a:solidFill>
+              <a:srgbClr val="30363D"/>
+            </a:solidFill>
+            <a:prstDash val="solid"/>
+          </a:ln>
+        </p:spPr>
+      </p:sp>
+      <p:sp>
+        <p:nvSpPr>
+          <p:cNvPr id="10" name="Text 7"/>
+          <p:cNvSpPr txBox="1"/>
+          <p:nvPr/>
+        </p:nvSpPr>
+        <p:spPr>
+          <a:xfrm>
+            <a:off x="8641080" y="1783080"/>
+            <a:ext cx="2743200" cy="411480"/>
+          </a:xfrm>
+          <a:prstGeom prst="rect">
+            <a:avLst/>
+          </a:prstGeom>
+          <a:noFill/>
+          <a:ln/>
+        </p:spPr>
+        <p:txBody>
+          <a:bodyPr wrap="square" lIns="0" tIns="0" rIns="0" bIns="0" rtlCol="0" anchor="t"/>
+          <a:lstStyle/>
+          <a:p>
+            <a:pPr indent="0" marL="0">
+              <a:buNone/>
+            </a:pPr>
+            <a:r>
+              <a:rPr lang="en-US" sz="1800" b="1" dirty="0">
+                <a:solidFill>
+                  <a:srgbClr val="F5A623"/>
+                </a:solidFill>
+                <a:latin typeface="Cambria" pitchFamily="34" charset="0"/>
+                <a:ea typeface="Cambria" pitchFamily="34" charset="-122"/>
+                <a:cs typeface="Cambria" pitchFamily="34" charset="-120"/>
+              </a:rPr>
+              <a:t>Tanpa diberi tahu</a:t>
+            </a:r>
+            <a:endParaRPr lang="en-US" sz="1800" dirty="0"/>
+          </a:p>
+        </p:txBody>
+      </p:sp>
+      <p:sp>
+        <p:nvSpPr>
+          <p:cNvPr id="11" name="Text 8"/>
+          <p:cNvSpPr txBox="1"/>
+          <p:nvPr/>
+        </p:nvSpPr>
+        <p:spPr>
+          <a:xfrm>
+            <a:off x="8641080" y="2240280"/>
+            <a:ext cx="2743200" cy="2423160"/>
+          </a:xfrm>
+          <a:prstGeom prst="rect">
+            <a:avLst/>
+          </a:prstGeom>
+          <a:noFill/>
+          <a:ln/>
+        </p:spPr>
+        <p:txBody>
+          <a:bodyPr wrap="square" lIns="0" tIns="0" rIns="0" bIns="0" rtlCol="0" anchor="t"/>
+          <a:lstStyle/>
+          <a:p>
+            <a:pPr indent="0" marL="0">
+              <a:spcAft>
+                <a:spcPts val="400"/>
+              </a:spcAft>
+              <a:buNone/>
+            </a:pPr>
+            <a:r>
+              <a:rPr lang="en-US" sz="1500" dirty="0">
+                <a:solidFill>
+                  <a:srgbClr val="A9B4C2"/>
+                </a:solidFill>
+                <a:latin typeface="Calibri" pitchFamily="34" charset="0"/>
+                <a:ea typeface="Calibri" pitchFamily="34" charset="-122"/>
+                <a:cs typeface="Calibri" pitchFamily="34" charset="-120"/>
+              </a:rPr>
+              <a:t>Decision Tree memisahkan data di pity_ratio ±0,72, sekitar 10 pull sebelum soft pity.</a:t>
             </a:r>
             <a:endParaRPr lang="en-US" sz="1500" dirty="0"/>
           </a:p>
@@ -15501,6 +15940,381 @@
                 <a:ea typeface="Calibri" pitchFamily="34" charset="-122"/>
                 <a:cs typeface="Calibri" pitchFamily="34" charset="-120"/>
               </a:rPr>
+              <a:t>PEMBAHASAN</a:t>
+            </a:r>
+            <a:endParaRPr lang="en-US" sz="1200" dirty="0"/>
+          </a:p>
+        </p:txBody>
+      </p:sp>
+      <p:sp>
+        <p:nvSpPr>
+          <p:cNvPr id="3" name="Text 1"/>
+          <p:cNvSpPr txBox="1"/>
+          <p:nvPr/>
+        </p:nvSpPr>
+        <p:spPr>
+          <a:xfrm>
+            <a:off x="548640" y="685800"/>
+            <a:ext cx="11091672" cy="731520"/>
+          </a:xfrm>
+          <a:prstGeom prst="rect">
+            <a:avLst/>
+          </a:prstGeom>
+          <a:noFill/>
+          <a:ln/>
+        </p:spPr>
+        <p:txBody>
+          <a:bodyPr wrap="square" lIns="0" tIns="0" rIns="0" bIns="0" rtlCol="0" anchor="ctr"/>
+          <a:lstStyle/>
+          <a:p>
+            <a:pPr indent="0" marL="0">
+              <a:buNone/>
+            </a:pPr>
+            <a:r>
+              <a:rPr lang="en-US" sz="3200" b="1" dirty="0">
+                <a:solidFill>
+                  <a:srgbClr val="E6EDF3"/>
+                </a:solidFill>
+                <a:latin typeface="Cambria" pitchFamily="34" charset="0"/>
+                <a:ea typeface="Cambria" pitchFamily="34" charset="-122"/>
+                <a:cs typeface="Cambria" pitchFamily="34" charset="-120"/>
+              </a:rPr>
+              <a:t>Confusion matrix &amp; feature importance</a:t>
+            </a:r>
+            <a:endParaRPr lang="en-US" sz="3200" dirty="0"/>
+          </a:p>
+        </p:txBody>
+      </p:sp>
+      <p:sp>
+        <p:nvSpPr>
+          <p:cNvPr id="4" name="Text 2"/>
+          <p:cNvSpPr txBox="1"/>
+          <p:nvPr/>
+        </p:nvSpPr>
+        <p:spPr>
+          <a:xfrm>
+            <a:off x="548640" y="6400800"/>
+            <a:ext cx="7315200" cy="228600"/>
+          </a:xfrm>
+          <a:prstGeom prst="rect">
+            <a:avLst/>
+          </a:prstGeom>
+          <a:noFill/>
+          <a:ln/>
+        </p:spPr>
+        <p:txBody>
+          <a:bodyPr wrap="square" lIns="0" tIns="0" rIns="0" bIns="0" rtlCol="0" anchor="ctr"/>
+          <a:lstStyle/>
+          <a:p>
+            <a:pPr indent="0" marL="0">
+              <a:buNone/>
+            </a:pPr>
+            <a:r>
+              <a:rPr lang="en-US" sz="1000" dirty="0">
+                <a:solidFill>
+                  <a:srgbClr val="8B949E"/>
+                </a:solidFill>
+                <a:latin typeface="Calibri" pitchFamily="34" charset="0"/>
+                <a:ea typeface="Calibri" pitchFamily="34" charset="-122"/>
+                <a:cs typeface="Calibri" pitchFamily="34" charset="-120"/>
+              </a:rPr>
+              <a:t>ZZZ Gacha Predictor · Kelompok 6 · A11.4502</a:t>
+            </a:r>
+            <a:endParaRPr lang="en-US" sz="1000" dirty="0"/>
+          </a:p>
+        </p:txBody>
+      </p:sp>
+      <p:sp>
+        <p:nvSpPr>
+          <p:cNvPr id="5" name="Text 3"/>
+          <p:cNvSpPr txBox="1"/>
+          <p:nvPr/>
+        </p:nvSpPr>
+        <p:spPr>
+          <a:xfrm>
+            <a:off x="10725912" y="6400800"/>
+            <a:ext cx="914400" cy="228600"/>
+          </a:xfrm>
+          <a:prstGeom prst="rect">
+            <a:avLst/>
+          </a:prstGeom>
+          <a:noFill/>
+          <a:ln/>
+        </p:spPr>
+        <p:txBody>
+          <a:bodyPr wrap="square" lIns="0" tIns="0" rIns="0" bIns="0" rtlCol="0" anchor="ctr"/>
+          <a:lstStyle/>
+          <a:p>
+            <a:pPr algn="r" indent="0" marL="0">
+              <a:buNone/>
+            </a:pPr>
+            <a:r>
+              <a:rPr lang="en-US" sz="1000" dirty="0">
+                <a:solidFill>
+                  <a:srgbClr val="8B949E"/>
+                </a:solidFill>
+                <a:latin typeface="Calibri" pitchFamily="34" charset="0"/>
+                <a:ea typeface="Calibri" pitchFamily="34" charset="-122"/>
+                <a:cs typeface="Calibri" pitchFamily="34" charset="-120"/>
+              </a:rPr>
+              <a:t>20</a:t>
+            </a:r>
+            <a:endParaRPr lang="en-US" sz="1000" dirty="0"/>
+          </a:p>
+        </p:txBody>
+      </p:sp>
+      <p:sp>
+        <p:nvSpPr>
+          <p:cNvPr id="6" name="Shape 4"/>
+          <p:cNvSpPr/>
+          <p:nvPr/>
+        </p:nvSpPr>
+        <p:spPr>
+          <a:xfrm>
+            <a:off x="438912" y="1602694"/>
+            <a:ext cx="6986016" cy="2372452"/>
+          </a:xfrm>
+          <a:prstGeom prst="roundRect">
+            <a:avLst>
+              <a:gd name="adj" fmla="val 2313"/>
+            </a:avLst>
+          </a:prstGeom>
+          <a:solidFill>
+            <a:srgbClr val="FFFFFF"/>
+          </a:solidFill>
+          <a:ln w="12700">
+            <a:solidFill>
+              <a:srgbClr val="30363D"/>
+            </a:solidFill>
+            <a:prstDash val="solid"/>
+          </a:ln>
+        </p:spPr>
+      </p:sp>
+      <p:pic>
+        <p:nvPicPr>
+          <p:cNvPr id="7" name="Image 0" descr="fig_cm.png">    </p:cNvPr>
+          <p:cNvPicPr>
+            <a:picLocks noChangeAspect="1"/>
+          </p:cNvPicPr>
+          <p:nvPr/>
+        </p:nvPicPr>
+        <p:blipFill>
+          <a:blip r:embed="rId1"/>
+          <a:stretch>
+            <a:fillRect/>
+          </a:stretch>
+        </p:blipFill>
+        <p:spPr>
+          <a:xfrm>
+            <a:off x="548640" y="1712422"/>
+            <a:ext cx="6766560" cy="2152996"/>
+          </a:xfrm>
+          <a:prstGeom prst="rect">
+            <a:avLst/>
+          </a:prstGeom>
+        </p:spPr>
+      </p:pic>
+      <p:sp>
+        <p:nvSpPr>
+          <p:cNvPr id="8" name="Shape 5"/>
+          <p:cNvSpPr/>
+          <p:nvPr/>
+        </p:nvSpPr>
+        <p:spPr>
+          <a:xfrm>
+            <a:off x="7479792" y="1824228"/>
+            <a:ext cx="4242816" cy="1929384"/>
+          </a:xfrm>
+          <a:prstGeom prst="roundRect">
+            <a:avLst>
+              <a:gd name="adj" fmla="val 2844"/>
+            </a:avLst>
+          </a:prstGeom>
+          <a:solidFill>
+            <a:srgbClr val="FFFFFF"/>
+          </a:solidFill>
+          <a:ln w="12700">
+            <a:solidFill>
+              <a:srgbClr val="30363D"/>
+            </a:solidFill>
+            <a:prstDash val="solid"/>
+          </a:ln>
+        </p:spPr>
+      </p:sp>
+      <p:pic>
+        <p:nvPicPr>
+          <p:cNvPr id="9" name="Image 1" descr="fig_importance.png">    </p:cNvPr>
+          <p:cNvPicPr>
+            <a:picLocks noChangeAspect="1"/>
+          </p:cNvPicPr>
+          <p:nvPr/>
+        </p:nvPicPr>
+        <p:blipFill>
+          <a:blip r:embed="rId2"/>
+          <a:stretch>
+            <a:fillRect/>
+          </a:stretch>
+        </p:blipFill>
+        <p:spPr>
+          <a:xfrm>
+            <a:off x="7589520" y="1933956"/>
+            <a:ext cx="4023360" cy="1709928"/>
+          </a:xfrm>
+          <a:prstGeom prst="rect">
+            <a:avLst/>
+          </a:prstGeom>
+        </p:spPr>
+      </p:pic>
+      <p:sp>
+        <p:nvSpPr>
+          <p:cNvPr id="10" name="Text 6"/>
+          <p:cNvSpPr txBox="1"/>
+          <p:nvPr/>
+        </p:nvSpPr>
+        <p:spPr>
+          <a:xfrm>
+            <a:off x="548640" y="4389120"/>
+            <a:ext cx="10972800" cy="1828800"/>
+          </a:xfrm>
+          <a:prstGeom prst="rect">
+            <a:avLst/>
+          </a:prstGeom>
+          <a:noFill/>
+          <a:ln/>
+        </p:spPr>
+        <p:txBody>
+          <a:bodyPr wrap="square" lIns="0" tIns="0" rIns="0" bIns="0" rtlCol="0" anchor="t"/>
+          <a:lstStyle/>
+          <a:p>
+            <a:pPr marL="228600" indent="-228600">
+              <a:spcAft>
+                <a:spcPts val="1000"/>
+              </a:spcAft>
+              <a:buSzPct val="100000"/>
+              <a:buChar char="•"/>
+            </a:pPr>
+            <a:r>
+              <a:rPr lang="en-US" sz="1500" dirty="0">
+                <a:solidFill>
+                  <a:srgbClr val="E6EDF3"/>
+                </a:solidFill>
+                <a:latin typeface="Calibri" pitchFamily="34" charset="0"/>
+                <a:ea typeface="Calibri" pitchFamily="34" charset="-122"/>
+                <a:cs typeface="Calibri" pitchFamily="34" charset="-120"/>
+              </a:rPr>
+              <a:t>Baseline tidak pernah menebak "dapat S" → recall 0</a:t>
+            </a:r>
+            <a:endParaRPr lang="en-US" sz="1500" dirty="0"/>
+          </a:p>
+          <a:p>
+            <a:pPr marL="228600" indent="-228600">
+              <a:spcAft>
+                <a:spcPts val="1000"/>
+              </a:spcAft>
+              <a:buSzPct val="100000"/>
+              <a:buChar char="•"/>
+            </a:pPr>
+            <a:r>
+              <a:rPr lang="en-US" sz="1500" dirty="0">
+                <a:solidFill>
+                  <a:srgbClr val="E6EDF3"/>
+                </a:solidFill>
+                <a:latin typeface="Calibri" pitchFamily="34" charset="0"/>
+                <a:ea typeface="Calibri" pitchFamily="34" charset="-122"/>
+                <a:cs typeface="Calibri" pitchFamily="34" charset="-120"/>
+              </a:rPr>
+              <a:t>XGBoost menangkap sebagian besar S di sekitar soft pity</a:t>
+            </a:r>
+            <a:endParaRPr lang="en-US" sz="1500" dirty="0"/>
+          </a:p>
+          <a:p>
+            <a:pPr marL="228600" indent="-228600">
+              <a:spcAft>
+                <a:spcPts val="1000"/>
+              </a:spcAft>
+              <a:buSzPct val="100000"/>
+              <a:buChar char="•"/>
+            </a:pPr>
+            <a:r>
+              <a:rPr lang="en-US" sz="1500" dirty="0">
+                <a:solidFill>
+                  <a:srgbClr val="E6EDF3"/>
+                </a:solidFill>
+                <a:latin typeface="Calibri" pitchFamily="34" charset="0"/>
+                <a:ea typeface="Calibri" pitchFamily="34" charset="-122"/>
+                <a:cs typeface="Calibri" pitchFamily="34" charset="-120"/>
+              </a:rPr>
+              <a:t>pity_ratio paling penting; guaranteed ≈ 0 (benar menurut aturan game: guaranteed hanya menentukan S mana, bukan kapan)</a:t>
+            </a:r>
+            <a:endParaRPr lang="en-US" sz="1500" dirty="0"/>
+          </a:p>
+        </p:txBody>
+      </p:sp>
+    </p:spTree>
+  </p:cSld>
+  <p:clrMapOvr>
+    <a:masterClrMapping/>
+  </p:clrMapOvr>
+</p:sld>
+</file>
+
+<file path=ppt/slides/slide21.xml><?xml version="1.0" encoding="utf-8"?>
+<p:sld xmlns:a="http://schemas.openxmlformats.org/drawingml/2006/main" xmlns:r="http://schemas.openxmlformats.org/officeDocument/2006/relationships" xmlns:p="http://schemas.openxmlformats.org/presentationml/2006/main">
+  <p:cSld name="Slide 21">
+    <p:bg>
+      <p:bgPr>
+        <a:solidFill>
+          <a:srgbClr val="0E1117"/>
+        </a:solidFill>
+      </p:bgPr>
+    </p:bg>
+    <p:spTree>
+      <p:nvGrpSpPr>
+        <p:cNvPr id="1" name=""/>
+        <p:cNvGrpSpPr/>
+        <p:nvPr/>
+      </p:nvGrpSpPr>
+      <p:grpSpPr>
+        <a:xfrm>
+          <a:off x="0" y="0"/>
+          <a:ext cx="0" cy="0"/>
+          <a:chOff x="0" y="0"/>
+          <a:chExt cx="0" cy="0"/>
+        </a:xfrm>
+      </p:grpSpPr>
+      <p:sp>
+        <p:nvSpPr>
+          <p:cNvPr id="2" name="Text 0"/>
+          <p:cNvSpPr txBox="1"/>
+          <p:nvPr/>
+        </p:nvSpPr>
+        <p:spPr>
+          <a:xfrm>
+            <a:off x="548640" y="411480"/>
+            <a:ext cx="9144000" cy="274320"/>
+          </a:xfrm>
+          <a:prstGeom prst="rect">
+            <a:avLst/>
+          </a:prstGeom>
+          <a:noFill/>
+          <a:ln/>
+        </p:spPr>
+        <p:txBody>
+          <a:bodyPr wrap="square" lIns="0" tIns="0" rIns="0" bIns="0" rtlCol="0" anchor="ctr"/>
+          <a:lstStyle/>
+          <a:p>
+            <a:pPr indent="0" marL="0">
+              <a:buNone/>
+            </a:pPr>
+            <a:r>
+              <a:rPr lang="en-US" sz="1200" b="1" spc="300" kern="0" dirty="0">
+                <a:solidFill>
+                  <a:srgbClr val="F5A623"/>
+                </a:solidFill>
+                <a:latin typeface="Calibri" pitchFamily="34" charset="0"/>
+                <a:ea typeface="Calibri" pitchFamily="34" charset="-122"/>
+                <a:cs typeface="Calibri" pitchFamily="34" charset="-120"/>
+              </a:rPr>
               <a:t>PENUTUP</a:t>
             </a:r>
             <a:endParaRPr lang="en-US" sz="1200" dirty="0"/>
@@ -15618,7 +16432,7 @@
                 <a:ea typeface="Calibri" pitchFamily="34" charset="-122"/>
                 <a:cs typeface="Calibri" pitchFamily="34" charset="-120"/>
               </a:rPr>
-              <a:t>20</a:t>
+              <a:t>21</a:t>
             </a:r>
             <a:endParaRPr lang="en-US" sz="1000" dirty="0"/>
           </a:p>
@@ -15952,7 +16766,7 @@
                 <a:ea typeface="Calibri" pitchFamily="34" charset="-122"/>
                 <a:cs typeface="Calibri" pitchFamily="34" charset="-120"/>
               </a:rPr>
-              <a:t>Decision Tree, Random Forest, XGBoost, KNN: ±91% simulasi, ±93% data asli.</a:t>
+              <a:t>Decision Tree, Random Forest, XGBoost konsisten terbaik: ±91% simulasi, ±93% data asli, juga saat dilatih di data asli saja.</a:t>
             </a:r>
             <a:endParaRPr lang="en-US" sz="1500" dirty="0"/>
           </a:p>
@@ -16158,7 +16972,7 @@
                 <a:ea typeface="Calibri" pitchFamily="34" charset="-122"/>
                 <a:cs typeface="Calibri" pitchFamily="34" charset="-120"/>
               </a:rPr>
-              <a:t>Saran: tambah akun data asli, estimasi soft pity dari data, perluas ke banner lain, impor dari Android.</a:t>
+              <a:t>Saran: tambah akun data asli, sesuaikan hyperparameter (k pada KNN) dengan grid search, estimasi soft pity dari data, perluas ke banner lain.</a:t>
             </a:r>
             <a:endParaRPr lang="en-US" sz="1500" dirty="0"/>
           </a:p>
@@ -16172,9 +16986,9 @@
 </p:sld>
 </file>
 
-<file path=ppt/slides/slide21.xml><?xml version="1.0" encoding="utf-8"?>
+<file path=ppt/slides/slide22.xml><?xml version="1.0" encoding="utf-8"?>
 <p:sld xmlns:a="http://schemas.openxmlformats.org/drawingml/2006/main" xmlns:r="http://schemas.openxmlformats.org/officeDocument/2006/relationships" xmlns:p="http://schemas.openxmlformats.org/presentationml/2006/main">
-  <p:cSld name="Slide 21">
+  <p:cSld name="Slide 22">
     <p:bg>
       <p:bgPr>
         <a:solidFill>

</xml_diff>

<commit_message>
Rapikan aplikasi, tambah logo Udinus, dan simpan sumber dokumen tugas
Aplikasi:
- Panduan: perintah PowerShell satu baris menunjuk branch yang benar
  (link ke main menghasilkan 404).
- Kalkulator: label "Encrypted Master Tape" (mata uang banner terbatas).
- Statistik: judul grafik W-Engine menyebut 75/25, bukan 50/50.
- Perbandingan: tabel cross-validation memakai satu fungsi cv_table.
- README: 6 model ML, 87 test, branch deploy yang benar.

Dokumen tugas:
- Logo Udinus di sampul proposal, laporan, dan kedua slide.
- Sampul tanpa nomor halaman, halaman depan bernomor romawi,
  BAB I mulai dari halaman 1.
- Tambah Daftar Tabel dan Daftar Gambar (nomor halaman otomatis).
- Tabel pendek tidak lagi terpotong ke halaman berikutnya.
- Jumlah test diperbarui menjadi 87.
- Kode pembuat docx/pptx dan gambarnya disimpan di docs/tugas/sumber/
  supaya bisa dibuat ulang (bash build.sh).
</commit_message>
<xml_diff>
--- a/docs/tugas/UAS_Slide_Kelompok6_A11.4502.pptx
+++ b/docs/tugas/UAS_Slide_Kelompok6_A11.4502.pptx
@@ -1704,7 +1704,7 @@
           <a:p>
             <a:r>
               <a:rPr lang="en-US" dirty="0"/>
-              <a:t>Validasi (±1 menit). Angka pity yang dihitung aplikasi untuk akun asli sama persis dengan yang tampil di game. Selain itu 86 test otomatis memastikan perhitungan tidak salah.</a:t>
+              <a:t>Validasi (±1 menit). Angka pity yang dihitung aplikasi untuk akun asli sama persis dengan yang tampil di game. Selain itu 87 test otomatis memastikan perhitungan tidak salah.</a:t>
             </a:r>
             <a:endParaRPr lang="en-US" dirty="0"/>
           </a:p>
@@ -3582,16 +3582,40 @@
           </a:p>
         </p:txBody>
       </p:sp>
-      <p:sp>
-        <p:nvSpPr>
-          <p:cNvPr id="5" name="Text 3"/>
+      <p:pic>
+        <p:nvPicPr>
+          <p:cNvPr id="5" name="Image 0" descr="Logo Universitas Dian Nuswantoro">    </p:cNvPr>
+          <p:cNvPicPr>
+            <a:picLocks noChangeAspect="1"/>
+          </p:cNvPicPr>
+          <p:nvPr/>
+        </p:nvPicPr>
+        <p:blipFill>
+          <a:blip r:embed="rId1"/>
+          <a:stretch>
+            <a:fillRect/>
+          </a:stretch>
+        </p:blipFill>
+        <p:spPr>
+          <a:xfrm>
+            <a:off x="548640" y="365760"/>
+            <a:ext cx="914400" cy="914400"/>
+          </a:xfrm>
+          <a:prstGeom prst="rect">
+            <a:avLst/>
+          </a:prstGeom>
+        </p:spPr>
+      </p:pic>
+      <p:sp>
+        <p:nvSpPr>
+          <p:cNvPr id="6" name="Text 3"/>
           <p:cNvSpPr txBox="1"/>
           <p:nvPr/>
         </p:nvSpPr>
         <p:spPr>
           <a:xfrm>
-            <a:off x="548640" y="914400"/>
-            <a:ext cx="7315200" cy="365760"/>
+            <a:off x="1645920" y="640080"/>
+            <a:ext cx="6766560" cy="365760"/>
           </a:xfrm>
           <a:prstGeom prst="rect">
             <a:avLst/>
@@ -3623,7 +3647,7 @@
       </p:sp>
       <p:sp>
         <p:nvSpPr>
-          <p:cNvPr id="6" name="Text 4"/>
+          <p:cNvPr id="7" name="Text 4"/>
           <p:cNvSpPr txBox="1"/>
           <p:nvPr/>
         </p:nvSpPr>
@@ -3662,7 +3686,7 @@
       </p:sp>
       <p:sp>
         <p:nvSpPr>
-          <p:cNvPr id="7" name="Text 5"/>
+          <p:cNvPr id="8" name="Text 5"/>
           <p:cNvSpPr txBox="1"/>
           <p:nvPr/>
         </p:nvSpPr>
@@ -3701,7 +3725,7 @@
       </p:sp>
       <p:sp>
         <p:nvSpPr>
-          <p:cNvPr id="8" name="Text 6"/>
+          <p:cNvPr id="9" name="Text 6"/>
           <p:cNvSpPr txBox="1"/>
           <p:nvPr/>
         </p:nvSpPr>
@@ -3803,7 +3827,7 @@
       </p:sp>
       <p:sp>
         <p:nvSpPr>
-          <p:cNvPr id="9" name="Text 7"/>
+          <p:cNvPr id="10" name="Text 7"/>
           <p:cNvSpPr txBox="1"/>
           <p:nvPr/>
         </p:nvSpPr>
@@ -6565,7 +6589,7 @@
                 <a:ea typeface="Cambria" pitchFamily="34" charset="-122"/>
                 <a:cs typeface="Cambria" pitchFamily="34" charset="-120"/>
               </a:rPr>
-              <a:t>86 / 86</a:t>
+              <a:t>87 / 87</a:t>
             </a:r>
             <a:endParaRPr lang="en-US" sz="5400" dirty="0"/>
           </a:p>

</xml_diff>

<commit_message>
Perbarui data asli akun01 (+17 pull) dan semua hasilnya
Data akun01 bertambah 17 pull W-Engine (S rate-up di pity 67); akun02
tetap. Total data asli kini 1.441 pull dan 22 S-Rank. Data divalidasi:
pity berurutan, reset setelah S, dan status guaranteed konsisten.

- Latih ulang: hasil simulasi tidak berubah (selisih < 1e-15), jadi
  models.joblib tetap; report.json memuat hasil data asli terbaru.
- Latih-uji data asli saja (tugas B, 1.209 baris): Decision Tree tetap
  tertinggi (93,10%), lalu Random Forest (92,99%) dan XGBoost (92,22%).
- Aplikasi: perkiraan ukuran data latih KNN dihitung dari report.
- README, LAPORAN.md, panduan pengumpulan, proposal, laporan, dan kedua
  slide memakai angka terbaru; grafik dibuat ulang lewat figs.py dan
  tangkapan layar halaman Perbandingan diambil ulang.

Co-Authored-By: Claude Opus 5.5 <noreply@anthropic.com>
Claude-Session: https://claude.ai/code/session_01EfDzNu9t2ibrydK84RyJqZ
</commit_message>
<xml_diff>
--- a/docs/tugas/UAS_Slide_Kelompok6_A11.4502.pptx
+++ b/docs/tugas/UAS_Slide_Kelompok6_A11.4502.pptx
@@ -368,13 +368,13 @@
                 <c:formatCode>General</c:formatCode>
                 <c:ptCount val="8"/>
                 <c:pt idx="0">
-                  <c:v>86.5</c:v>
+                  <c:v>86.6</c:v>
                 </c:pt>
                 <c:pt idx="1">
                   <c:v>93.5</c:v>
                 </c:pt>
                 <c:pt idx="2">
-                  <c:v>87.7</c:v>
+                  <c:v>87.5</c:v>
                 </c:pt>
                 <c:pt idx="3">
                   <c:v>93.5</c:v>
@@ -590,7 +590,7 @@
                 </a:solidFill>
                 <a:latin typeface="Arial"/>
               </a:rPr>
-              <a:t>Accuracy (%) — 1.192 baris data asli, 5-fold per siklus pity</a:t>
+              <a:t>Accuracy (%) — 1.209 baris data asli, 5-fold per siklus pity</a:t>
             </a:r>
           </a:p>
         </c:rich>
@@ -691,28 +691,28 @@
                 <c:formatCode>General</c:formatCode>
                 <c:ptCount val="8"/>
                 <c:pt idx="0">
-                  <c:v>86.4</c:v>
+                  <c:v>86.6</c:v>
                 </c:pt>
                 <c:pt idx="1">
-                  <c:v>93.6</c:v>
+                  <c:v>93.7</c:v>
                 </c:pt>
                 <c:pt idx="2">
-                  <c:v>88</c:v>
+                  <c:v>87.9</c:v>
                 </c:pt>
                 <c:pt idx="3">
                   <c:v>87.4</c:v>
                 </c:pt>
                 <c:pt idx="4">
-                  <c:v>91</c:v>
+                  <c:v>90.7</c:v>
                 </c:pt>
                 <c:pt idx="5">
+                  <c:v>93.1</c:v>
+                </c:pt>
+                <c:pt idx="6">
                   <c:v>93</c:v>
                 </c:pt>
-                <c:pt idx="6">
-                  <c:v>92.9</c:v>
-                </c:pt>
                 <c:pt idx="7">
-                  <c:v>92.6</c:v>
+                  <c:v>92.2</c:v>
                 </c:pt>
               </c:numCache>
             </c:numRef>
@@ -1352,7 +1352,7 @@
           <a:p>
             <a:r>
               <a:rPr lang="en-US" dirty="0"/>
-              <a:t>Data (±1,5 menit). Riwayat satu akun terlalu sedikit untuk melatih model, jadi data latih memakai simulasi Monte Carlo dari model Markov, 400 akun. Data asli dua akun, 1.424 baris, sudah memenuhi syarat dataset tabel minimal 500 sampai 1000 baris. Data asli dipakai untuk menguji, dan di eksperimen kedua keenam algoritma juga dilatih dan diuji hanya dengan data asli. Jelaskan cara pengambilan data asli lewat script PowerShell yang hanya membaca cache game, dan bahwa authkey tidak disimpan.</a:t>
+              <a:t>Data (±1,5 menit). Riwayat satu akun terlalu sedikit untuk melatih model, jadi data latih memakai simulasi Monte Carlo dari model Markov, 400 akun. Data asli dua akun, 1.441 pull, sudah memenuhi syarat dataset tabel minimal 500 sampai 1000 baris. Data asli dipakai untuk menguji, dan di eksperimen kedua keenam algoritma juga dilatih dan diuji hanya dengan data asli. Jelaskan cara pengambilan data asli lewat script PowerShell yang hanya membaca cache game, dan bahwa authkey tidak disimpan.</a:t>
             </a:r>
             <a:endParaRPr lang="en-US" dirty="0"/>
           </a:p>
@@ -2056,7 +2056,7 @@
           <a:p>
             <a:r>
               <a:rPr lang="en-US" dirty="0"/>
-              <a:t>Eksperimen kedua (±2 menit). Untuk menjawab apakah model hanya bagus di data simulasi, kami melatih dan menguji keenam algoritma hanya dengan data asli: 1.192 baris dari 2 akun, sudah di atas syarat 500 sampai 1000 baris. Data dibagi per siklus pity menjadi 5 bagian. Hasilnya: Decision Tree 93,0 persen, Random Forest 92,9 persen, XGBoost 92,6 persen, urutannya sama seperti di simulasi dan hampir menyamai batas teori Markov 93,6 persen. Logistic Regression 91,0 persen dan Naive Bayes 88,0 persen. KNN turun ke 87,4 persen karena nilai k = 101 terlalu besar untuk data sekecil ini, jadi KNN hampir selalu menebak kelas mayoritas. Pelajarannya: hyperparameter harus disesuaikan dengan ukuran data.</a:t>
+              <a:t>Eksperimen kedua (±2 menit). Untuk menjawab apakah model hanya bagus di data simulasi, kami melatih dan menguji keenam algoritma hanya dengan data asli: 1.209 baris dari 2 akun, sudah di atas syarat 500 sampai 1000 baris. Data dibagi per siklus pity menjadi 5 bagian. Hasilnya: Decision Tree 93,1 persen, Random Forest 93,0 persen, XGBoost 92,2 persen, urutannya sama seperti di simulasi dan hampir menyamai batas teori Markov 93,7 persen. Logistic Regression 90,7 persen dan Naive Bayes 87,9 persen. KNN turun ke 87,4 persen karena nilai k = 101 terlalu besar untuk data sekecil ini, jadi KNN hampir selalu menebak kelas mayoritas. Pelajarannya: hyperparameter harus disesuaikan dengan ukuran data.</a:t>
             </a:r>
             <a:endParaRPr lang="en-US" dirty="0"/>
           </a:p>
@@ -4262,7 +4262,7 @@
                 <a:ea typeface="Calibri" pitchFamily="34" charset="-122"/>
                 <a:cs typeface="Calibri" pitchFamily="34" charset="-120"/>
               </a:rPr>
-              <a:t>1.424 pull · 21 S-Rank · anonim. Dipakai untuk menguji model, dan dalam eksperimen kedua untuk melatih + menguji sendiri (1.192 baris).</a:t>
+              <a:t>1.441 pull · 22 S-Rank · anonim. Dipakai untuk menguji model, dan dalam eksperimen kedua untuk melatih + menguji sendiri (1.209 baris).</a:t>
             </a:r>
             <a:endParaRPr lang="en-US" sz="1600" dirty="0"/>
           </a:p>
@@ -13898,7 +13898,7 @@
                 <a:ea typeface="Calibri" pitchFamily="34" charset="-122"/>
                 <a:cs typeface="Calibri" pitchFamily="34" charset="-120"/>
               </a:rPr>
-              <a:t>Decision Tree 93,0%, Random Forest 92,9%, XGBoost 92,6%: urutan sama seperti di simulasi.</a:t>
+              <a:t>Decision Tree 93,1%, Random Forest 93,0%, XGBoost 92,2%: urutan sama seperti di simulasi.</a:t>
             </a:r>
             <a:endParaRPr lang="en-US" sz="1400" dirty="0"/>
           </a:p>
@@ -14006,7 +14006,7 @@
                 <a:ea typeface="Calibri" pitchFamily="34" charset="-122"/>
                 <a:cs typeface="Calibri" pitchFamily="34" charset="-120"/>
               </a:rPr>
-              <a:t>k = 101 terlalu besar untuk ±950 baris latih → hampir selalu menebak mayoritas.</a:t>
+              <a:t>k = 101 terlalu besar untuk ±970 baris latih → hampir selalu menebak mayoritas.</a:t>
             </a:r>
             <a:endParaRPr lang="en-US" sz="1400" dirty="0"/>
           </a:p>

</xml_diff>

<commit_message>
Salin beberapa URL dari cache dan lewati yang authkey-nya kedaluwarsa
- Script PowerShell 1.4 menyalin hingga 10 URL getGachaLog (authkey berbeda)
  dari cache, dimulai dari file cache yang paling baru. Urutan entri di file
  cache tidak selalu sesuai waktu, sehingga URL terakhir di file bisa saja
  URL lama yang sudah kedaluwarsa.
- Aplikasi menerima beberapa URL sekaligus, membuang authkey ganda, lalu
  mencobanya satu per satu dan melewati yang kedaluwarsa.
- Teks Import Data dan Panduan disesuaikan; jumlah test di README, laporan,
  dan slide diperbarui (106).
</commit_message>
<xml_diff>
--- a/docs/tugas/UAS_Slide_Kelompok6_A11.4502.pptx
+++ b/docs/tugas/UAS_Slide_Kelompok6_A11.4502.pptx
@@ -1796,7 +1796,7 @@
           <a:p>
             <a:r>
               <a:rPr lang="en-US" dirty="0"/>
-              <a:t>Validasi (±1 menit). Saat dicek, angka pity yang dihitung aplikasi untuk akun asli sama persis dengan yang tampil di game. Selain itu 99 test otomatis memastikan perhitungan tidak salah.</a:t>
+              <a:t>Validasi (±1 menit). Saat dicek, angka pity yang dihitung aplikasi untuk akun asli sama persis dengan yang tampil di game. Selain itu 106 test otomatis memastikan perhitungan tidak salah.</a:t>
             </a:r>
             <a:endParaRPr lang="en-US" dirty="0"/>
           </a:p>
@@ -8212,7 +8212,7 @@
                 <a:ea typeface="Cambria" pitchFamily="34" charset="-122"/>
                 <a:cs typeface="Cambria" pitchFamily="34" charset="-120"/>
               </a:rPr>
-              <a:t>99 / 99</a:t>
+              <a:t>106 / 106</a:t>
             </a:r>
             <a:endParaRPr lang="en-US" sz="5400" dirty="0"/>
           </a:p>

</xml_diff>

<commit_message>
Latih ulang dengan 3 akun asli dan perbarui dokumen
- Model dan report dilatih ulang dengan 3 akun asli (1.751 pull, 28 S-Rank;
  eksperimen data asli 1.425 baris, 25 siklus pity).
- Hasil data asli: Random Forest dan Decision Tree teratas (±92,3%), selisih
  antaralgoritma belum signifikan; hanya baseline yang nyata lebih rendah.
- Temuan baru: KNN dan XGBoost tidak stabil di satu fold karena data latihnya
  hanya punya satu siklus Agent guaranteed, sehingga keduanya mempelajari pola
  keliru dari fitur guaranteed. Dijelaskan di laporan, slide, dan PANDUAN.
- Grafik, tangkapan layar, LAPORAN.md, README, dan tanya jawab diperbarui;
  caption KNN di aplikasi diganti penjelasan umum tentang nested grid search.
</commit_message>
<xml_diff>
--- a/docs/tugas/UAS_Slide_Kelompok6_A11.4502.pptx
+++ b/docs/tugas/UAS_Slide_Kelompok6_A11.4502.pptx
@@ -295,7 +295,7 @@
               <c:strCache>
                 <c:ptCount val="1"/>
                 <c:pt idx="0">
-                  <c:v>Data asli (2 akun)</c:v>
+                  <c:v>Data asli (3 akun)</c:v>
                 </c:pt>
               </c:strCache>
             </c:strRef>
@@ -372,28 +372,28 @@
                 <c:formatCode>General</c:formatCode>
                 <c:ptCount val="8"/>
                 <c:pt idx="0">
-                  <c:v>86.6</c:v>
+                  <c:v>86.5</c:v>
                 </c:pt>
                 <c:pt idx="1">
-                  <c:v>93.5</c:v>
+                  <c:v>92.6</c:v>
                 </c:pt>
                 <c:pt idx="2">
-                  <c:v>91.1</c:v>
+                  <c:v>90.7</c:v>
                 </c:pt>
                 <c:pt idx="3">
-                  <c:v>93.1</c:v>
+                  <c:v>92.3</c:v>
                 </c:pt>
                 <c:pt idx="4">
-                  <c:v>91.1</c:v>
+                  <c:v>90.3</c:v>
                 </c:pt>
                 <c:pt idx="5">
-                  <c:v>93.3</c:v>
+                  <c:v>92.4</c:v>
                 </c:pt>
                 <c:pt idx="6">
-                  <c:v>93.3</c:v>
+                  <c:v>92.4</c:v>
                 </c:pt>
                 <c:pt idx="7">
-                  <c:v>93.4</c:v>
+                  <c:v>92.5</c:v>
                 </c:pt>
               </c:numCache>
             </c:numRef>
@@ -594,7 +594,7 @@
                 </a:solidFill>
                 <a:latin typeface="Arial"/>
               </a:rPr>
-              <a:t>Accuracy (%) — 1.209 baris data asli, 5-fold per siklus pity</a:t>
+              <a:t>Accuracy (%) — 1.425 baris data asli, 5-fold per siklus pity</a:t>
             </a:r>
           </a:p>
         </c:rich>
@@ -695,28 +695,28 @@
                 <c:formatCode>General</c:formatCode>
                 <c:ptCount val="8"/>
                 <c:pt idx="0">
-                  <c:v>86.6</c:v>
+                  <c:v>86.5</c:v>
                 </c:pt>
                 <c:pt idx="1">
-                  <c:v>93.7</c:v>
+                  <c:v>92.6</c:v>
                 </c:pt>
                 <c:pt idx="2">
-                  <c:v>91.5</c:v>
+                  <c:v>90.7</c:v>
                 </c:pt>
                 <c:pt idx="3">
-                  <c:v>91</c:v>
+                  <c:v>85.3</c:v>
                 </c:pt>
                 <c:pt idx="4">
-                  <c:v>91.3</c:v>
+                  <c:v>91.4</c:v>
                 </c:pt>
                 <c:pt idx="5">
-                  <c:v>93.1</c:v>
+                  <c:v>92.3</c:v>
                 </c:pt>
                 <c:pt idx="6">
-                  <c:v>92.9</c:v>
+                  <c:v>92.4</c:v>
                 </c:pt>
                 <c:pt idx="7">
-                  <c:v>92.3</c:v>
+                  <c:v>89.7</c:v>
                 </c:pt>
               </c:numCache>
             </c:numRef>
@@ -1444,7 +1444,7 @@
           <a:p>
             <a:r>
               <a:rPr lang="en-US" dirty="0"/>
-              <a:t>Data (±1,5 menit). Riwayat satu akun terlalu sedikit untuk melatih model, jadi data latih memakai simulasi Monte Carlo dari model Markov, 400 akun. Karena simulasi dibuat dari model kami sendiri, model yang dilatih di simulasi hanya mempelajari ulang asumsi itu; karena itu data asli sangat penting. Data asli dua akun, 1.441 pull, sudah memenuhi syarat dataset tabel minimal 500 sampai 1000 baris. Data asli dipakai untuk menguji, dan di eksperimen kedua keenam algoritma juga dilatih dan diuji hanya dengan data asli. Jelaskan cara pengambilan data asli lewat script PowerShell yang hanya membaca cache game, dan bahwa authkey tidak disimpan.</a:t>
+              <a:t>Data (±1,5 menit). Riwayat satu akun terlalu sedikit untuk melatih model, jadi data latih memakai simulasi Monte Carlo dari model Markov, 400 akun. Karena simulasi dibuat dari model kami sendiri, model yang dilatih di simulasi hanya mempelajari ulang asumsi itu; karena itu data asli sangat penting. Data asli tiga akun, 1.751 pull, sudah memenuhi syarat dataset tabel minimal 500 sampai 1000 baris. Data asli dipakai untuk menguji, dan di eksperimen kedua keenam algoritma juga dilatih dan diuji hanya dengan data asli. Jelaskan cara pengambilan data asli lewat script PowerShell yang hanya membaca cache game, dan bahwa authkey tidak disimpan.</a:t>
             </a:r>
             <a:endParaRPr lang="en-US" dirty="0"/>
           </a:p>
@@ -1972,7 +1972,7 @@
           <a:p>
             <a:r>
               <a:rPr lang="en-US" dirty="0"/>
-              <a:t>Tugas B (±2 menit). Bacakan grafik. Decision Tree, Random Forest, XGBoost, dan KNN sekitar 91 persen di simulasi dan 93 persen di data asli, hampir sama dengan acuan teori Markov; selisih di antara keempatnya sangat kecil dan tidak signifikan, sehingga setara. Logistic Regression 88,9 persen dan Naive Bayes 89,2 persen setelah grid search; menurut uji signifikansi keduanya nyata lebih rendah. Baseline 83,4 persen. Kalau ditanya kenapa data asli lebih tinggi: kelas positifnya lebih sedikit, jadi baseline-nya juga lebih tinggi; keunggulan di atas baseline sama-sama sekitar 7 poin.</a:t>
+              <a:t>Tugas B (±2 menit). Bacakan grafik. Decision Tree, Random Forest, XGBoost, dan KNN sekitar 91 persen di simulasi dan 92 persen di data asli, hampir sama dengan acuan teori Markov; selisih di antara keempatnya sangat kecil dan tidak signifikan, sehingga setara. Logistic Regression 88,9 persen dan Naive Bayes 89,2 persen setelah grid search; menurut uji signifikansi keduanya nyata lebih rendah. Baseline 83,4 persen. Kalau ditanya kenapa data asli lebih tinggi: kelas positifnya lebih sedikit, jadi baseline-nya juga lebih tinggi; keunggulan di atas baseline sekitar 7,7 poin di simulasi dan 6,0 poin di data asli.</a:t>
             </a:r>
             <a:endParaRPr lang="en-US" dirty="0"/>
           </a:p>
@@ -2324,7 +2324,7 @@
           <a:p>
             <a:r>
               <a:rPr lang="en-US" dirty="0"/>
-              <a:t>Eksperimen kedua (±2 menit). Untuk menjawab apakah model hanya bagus di data simulasi, kami melatih dan menguji keenam algoritma hanya dengan data asli: 1.209 baris dari 2 akun, sudah di atas syarat 500 sampai 1000 baris. Data dibagi per siklus pity menjadi 5 bagian, dan grid search diulang di dalam setiap bagian supaya data uji tidak ikut memilih pengaturan. Hasilnya: Decision Tree 93,1%, Random Forest 92,9%, XGBoost 92,3%, hampir menyamai acuan teori Markov 93,7%. Grid search paling membantu Naive Bayes dan KNN: dengan pengaturan awal keduanya hampir sama dengan baseline, tetapi setelah dipilih ulang naik menjadi 91,5% dan 91,0%. KNN memilih k antara 5 dan 31, karena k = 101 terlalu besar untuk data latih sekitar 970 baris. Pelajarannya: hyperparameter harus disesuaikan dengan ukuran data.</a:t>
+              <a:t>Eksperimen kedua (±2 menit). Untuk menjawab apakah model hanya bagus di data simulasi, kami melatih dan menguji keenam algoritma hanya dengan data asli: 1.425 baris dari tiga akun, sudah di atas syarat 500 sampai 1000 baris. Data dibagi per siklus pity menjadi 5 bagian, dan grid search diulang di dalam setiap bagian supaya data uji tidak ikut memilih pengaturan. Hasilnya: Random Forest 92,4% dan Decision Tree 92,3%, hampir menyamai acuan teori Markov 92,6%. Grid search membantu Naive Bayes, dari 86,5% menjadi 90,7%. Temuan penting: KNN dan XGBoost tidak stabil. Di satu fold, data latihnya hanya memuat satu siklus Agent berstatus guaranteed yang kebetulan dapat S cepat, di pull ke-38. Dari satu siklus itu mereka belajar pola keliru "guaranteed berarti S segera keluar", lalu salah menebak pada siklus guaranteed lain yang ternyata panjang. Decision Tree dan Random Forest tidak terpengaruh karena aturan daun minimal 50 data. Pelajarannya: dengan data sedikit, fitur yang tidak relevan bisa menyesatkan model yang fleksibel.</a:t>
             </a:r>
             <a:endParaRPr lang="en-US" dirty="0"/>
           </a:p>
@@ -2412,7 +2412,7 @@
           <a:p>
             <a:r>
               <a:rPr lang="en-US" dirty="0"/>
-              <a:t>Uji signifikansi (±2 menit). Selisih akurasi yang kecil belum tentu nyata. Kami memakai uji t berpasangan terkoreksi dari Nadeau dan Bengio, yang cocok untuk hasil cross-validation karena data latih antarfold saling tumpang tindih. Di data simulasi, Decision Tree, Random Forest, dan KNN tidak berbeda nyata dari XGBoost, sedangkan Naive Bayes dan Logistic Regression nyata lebih rendah, p kurang dari 0,001. Di data asli, hanya baseline yang nyata lebih rendah dari Decision Tree; selisih antaralgoritma, paling besar sekitar 2 poin, belum signifikan karena data asli baru 20 siklus pity. Jadi kami tidak mengklaim Decision Tree pasti yang terbaik di data asli; yang bisa dikatakan, model pohon konsisten di urutan atas.</a:t>
+              <a:t>Uji signifikansi (±2 menit). Selisih akurasi yang kecil belum tentu nyata. Kami memakai uji t berpasangan terkoreksi dari Nadeau dan Bengio, yang cocok untuk hasil cross-validation karena data latih antarfold saling tumpang tindih. Di data simulasi, Decision Tree, Random Forest, dan KNN tidak berbeda nyata dari XGBoost, sedangkan Naive Bayes dan Logistic Regression nyata lebih rendah, p kurang dari 0,001. Di data asli, hanya baseline yang nyata lebih rendah dari Random Forest; selisih antaralgoritma, paling besar sekitar 2 poin, belum signifikan karena data asli baru 20 siklus pity. Jadi kami tidak mengklaim Decision Tree pasti yang terbaik di data asli; yang bisa dikatakan, model pohon konsisten di urutan atas.</a:t>
             </a:r>
             <a:endParaRPr lang="en-US" dirty="0"/>
           </a:p>
@@ -2500,7 +2500,7 @@
           <a:p>
             <a:r>
               <a:rPr lang="en-US" dirty="0"/>
-              <a:t>Pola soft pity (±2 menit). Ini jawaban rumusan kedua sekaligus alasan memakai data mining. Grafik membandingkan laju S per pull di data asli (batang oranye) dengan peluang model Markov (titik hitam). Agent: hampir nol sampai pull ke-73, lalu melonjak 14 persen di pull 74 sampai 78 dan 38 persen sesudahnya, hampir sama dengan model. W-Engine: 4 dari 11 pull setelah pull ke-65 dapat S, lebih tinggi dari model, tetapi datanya masih sedikit. Decision Tree yang dilatih hanya dengan data asli juga memisahkan data di sekitar pity 66, sekitar 10 pull sebelum soft pity, padahal tidak pernah diberi tahu soal soft pity.</a:t>
+              <a:t>Pola soft pity (±2 menit). Ini jawaban rumusan kedua sekaligus alasan memakai data mining. Grafik membandingkan laju S per pull di data asli (batang oranye) dengan peluang model Markov (garis hitam putus-putus). Agent: laju S 0,7% sampai pull ke-73, lalu melonjak menjadi 14% di pull 74 sampai 78 dan 38% di pull 79 sampai 90, mendekati model. W-Engine: 4 dari 11 pull setelah pull ke-65 dapat S, lebih tinggi daripada model. Decision Tree yang dilatih hanya dengan data asli juga memisahkan data di sekitar pity 65, sekitar 10 pull sebelum soft pity, padahal tidak pernah diberi tahu soal soft pity.</a:t>
             </a:r>
             <a:endParaRPr lang="en-US" dirty="0"/>
           </a:p>
@@ -5843,7 +5843,7 @@
                 <a:ea typeface="Cambria" pitchFamily="34" charset="-122"/>
                 <a:cs typeface="Cambria" pitchFamily="34" charset="-120"/>
               </a:rPr>
-              <a:t>Data asli (2 akun)</a:t>
+              <a:t>Data asli (3 akun)</a:t>
             </a:r>
             <a:endParaRPr lang="en-US" sz="1800" dirty="0"/>
           </a:p>
@@ -5885,7 +5885,7 @@
                 <a:ea typeface="Calibri" pitchFamily="34" charset="-122"/>
                 <a:cs typeface="Calibri" pitchFamily="34" charset="-120"/>
               </a:rPr>
-              <a:t>1.441 pull · 22 S-Rank · anonim. Dipakai untuk menguji model, memeriksa pola soft pity, dan melatih + menguji sendiri (1.209 baris).</a:t>
+              <a:t>1.751 pull · 28 S-Rank · anonim. Dipakai untuk menguji model, memeriksa pola soft pity, dan melatih + menguji sendiri (1.425 baris).</a:t>
             </a:r>
             <a:endParaRPr lang="en-US" sz="1600" dirty="0"/>
           </a:p>
@@ -11336,7 +11336,7 @@
                 <a:ea typeface="Calibri" pitchFamily="34" charset="-122"/>
                 <a:cs typeface="Calibri" pitchFamily="34" charset="-120"/>
               </a:rPr>
-              <a:t>Akurasi data asli lebih tinggi karena kelas positifnya lebih sedikit (13,4% vs 16,6%), sehingga baseline ikut naik (86,6% vs 83,4%). Keunggulan di atas baseline sama-sama ±7 poin.</a:t>
+              <a:t>Akurasi data asli lebih tinggi karena kelas positifnya lebih sedikit (13,5% vs 16,6%), sehingga baseline ikut naik (86,5% vs 83,4%). Keunggulan model terbaik di atas baseline: 7,7 poin (simulasi) dan 6,0 poin (data asli).</a:t>
             </a:r>
             <a:endParaRPr lang="en-US" sz="1400" dirty="0"/>
           </a:p>
@@ -18850,7 +18850,7 @@
                 <a:ea typeface="Cambria" pitchFamily="34" charset="-122"/>
                 <a:cs typeface="Cambria" pitchFamily="34" charset="-120"/>
               </a:rPr>
-              <a:t>Tetap teratas</a:t>
+              <a:t>Teratas</a:t>
             </a:r>
             <a:endParaRPr lang="en-US" sz="1800" dirty="0"/>
           </a:p>
@@ -18892,7 +18892,7 @@
                 <a:ea typeface="Calibri" pitchFamily="34" charset="-122"/>
                 <a:cs typeface="Calibri" pitchFamily="34" charset="-120"/>
               </a:rPr>
-              <a:t>Decision Tree 93,1%, Random Forest 92,9%, XGBoost 92,3%. Teori Markov 93,7%.</a:t>
+              <a:t>Random Forest 92,4%, Decision Tree 92,3%. Teori Markov 92,6%. Selisih belum signifikan.</a:t>
             </a:r>
             <a:endParaRPr lang="en-US" sz="1400" dirty="0"/>
           </a:p>
@@ -18958,7 +18958,7 @@
                 <a:ea typeface="Cambria" pitchFamily="34" charset="-122"/>
                 <a:cs typeface="Cambria" pitchFamily="34" charset="-120"/>
               </a:rPr>
-              <a:t>NB &amp; KNN naik</a:t>
+              <a:t>Ada yang goyah</a:t>
             </a:r>
             <a:endParaRPr lang="en-US" sz="1800" dirty="0"/>
           </a:p>
@@ -19000,7 +19000,7 @@
                 <a:ea typeface="Calibri" pitchFamily="34" charset="-122"/>
                 <a:cs typeface="Calibri" pitchFamily="34" charset="-120"/>
               </a:rPr>
-              <a:t>Naive Bayes 87,9% → 91,5%, KNN 87,4% → 91,0% (k = 5–31, bukan 101).</a:t>
+              <a:t>Di satu fold KNN cuma 65%, XGBoost cuma 77%: belajar pola keliru dari fitur guaranteed.</a:t>
             </a:r>
             <a:endParaRPr lang="en-US" sz="1400" dirty="0"/>
           </a:p>
@@ -19445,7 +19445,7 @@
                           <a:ea typeface="Calibri" pitchFamily="34" charset="-122"/>
                           <a:cs typeface="Calibri" pitchFamily="34" charset="-120"/>
                         </a:rPr>
-                        <a:t>vs Decision Tree (asli)</a:t>
+                        <a:t>vs Random Forest (asli)</a:t>
                       </a:r>
                       <a:endParaRPr lang="en-US" sz="1300" dirty="0">
                         <a:latin typeface="Calibri" charset="0"/>
@@ -19787,7 +19787,7 @@
                           <a:ea typeface="Calibri" pitchFamily="34" charset="-122"/>
                           <a:cs typeface="Calibri" pitchFamily="34" charset="-120"/>
                         </a:rPr>
-                        <a:t>−6,53</a:t>
+                        <a:t>−5,90</a:t>
                       </a:r>
                       <a:endParaRPr lang="en-US" sz="1300" dirty="0">
                         <a:latin typeface="Calibri" charset="0"/>
@@ -19855,7 +19855,7 @@
                           <a:ea typeface="Calibri" pitchFamily="34" charset="-122"/>
                           <a:cs typeface="Calibri" pitchFamily="34" charset="-120"/>
                         </a:rPr>
-                        <a:t>0,042</a:t>
+                        <a:t>0,003</a:t>
                       </a:r>
                       <a:endParaRPr lang="en-US" sz="1300" dirty="0">
                         <a:latin typeface="Calibri" charset="0"/>
@@ -20129,7 +20129,7 @@
                           <a:ea typeface="Calibri" pitchFamily="34" charset="-122"/>
                           <a:cs typeface="Calibri" pitchFamily="34" charset="-120"/>
                         </a:rPr>
-                        <a:t>+0,58</a:t>
+                        <a:t>+0,28</a:t>
                       </a:r>
                       <a:endParaRPr lang="en-US" sz="1300" dirty="0">
                         <a:latin typeface="Calibri" charset="0"/>
@@ -20197,7 +20197,7 @@
                           <a:ea typeface="Calibri" pitchFamily="34" charset="-122"/>
                           <a:cs typeface="Calibri" pitchFamily="34" charset="-120"/>
                         </a:rPr>
-                        <a:t>0,210</a:t>
+                        <a:t>0,541</a:t>
                       </a:r>
                       <a:endParaRPr lang="en-US" sz="1300" dirty="0">
                         <a:latin typeface="Calibri" charset="0"/>
@@ -20471,7 +20471,7 @@
                           <a:ea typeface="Calibri" pitchFamily="34" charset="-122"/>
                           <a:cs typeface="Calibri" pitchFamily="34" charset="-120"/>
                         </a:rPr>
-                        <a:t>−1,63</a:t>
+                        <a:t>−1,62</a:t>
                       </a:r>
                       <a:endParaRPr lang="en-US" sz="1300" dirty="0">
                         <a:latin typeface="Calibri" charset="0"/>
@@ -20539,7 +20539,7 @@
                           <a:ea typeface="Calibri" pitchFamily="34" charset="-122"/>
                           <a:cs typeface="Calibri" pitchFamily="34" charset="-120"/>
                         </a:rPr>
-                        <a:t>0,471</a:t>
+                        <a:t>0,297</a:t>
                       </a:r>
                       <a:endParaRPr lang="en-US" sz="1300" dirty="0">
                         <a:latin typeface="Calibri" charset="0"/>
@@ -20813,7 +20813,7 @@
                           <a:ea typeface="Calibri" pitchFamily="34" charset="-122"/>
                           <a:cs typeface="Calibri" pitchFamily="34" charset="-120"/>
                         </a:rPr>
-                        <a:t>−2,15</a:t>
+                        <a:t>−7,06</a:t>
                       </a:r>
                       <a:endParaRPr lang="en-US" sz="1300" dirty="0">
                         <a:latin typeface="Calibri" charset="0"/>
@@ -20881,7 +20881,7 @@
                           <a:ea typeface="Calibri" pitchFamily="34" charset="-122"/>
                           <a:cs typeface="Calibri" pitchFamily="34" charset="-120"/>
                         </a:rPr>
-                        <a:t>0,306</a:t>
+                        <a:t>0,409</a:t>
                       </a:r>
                       <a:endParaRPr lang="en-US" sz="1300" dirty="0">
                         <a:latin typeface="Calibri" charset="0"/>
@@ -21155,7 +21155,7 @@
                           <a:ea typeface="Calibri" pitchFamily="34" charset="-122"/>
                           <a:cs typeface="Calibri" pitchFamily="34" charset="-120"/>
                         </a:rPr>
-                        <a:t>−1,76</a:t>
+                        <a:t>−0,98</a:t>
                       </a:r>
                       <a:endParaRPr lang="en-US" sz="1300" dirty="0">
                         <a:latin typeface="Calibri" charset="0"/>
@@ -21223,7 +21223,7 @@
                           <a:ea typeface="Calibri" pitchFamily="34" charset="-122"/>
                           <a:cs typeface="Calibri" pitchFamily="34" charset="-120"/>
                         </a:rPr>
-                        <a:t>0,497</a:t>
+                        <a:t>0,193</a:t>
                       </a:r>
                       <a:endParaRPr lang="en-US" sz="1300" dirty="0">
                         <a:latin typeface="Calibri" charset="0"/>
@@ -21497,7 +21497,7 @@
                           <a:ea typeface="Calibri" pitchFamily="34" charset="-122"/>
                           <a:cs typeface="Calibri" pitchFamily="34" charset="-120"/>
                         </a:rPr>
-                        <a:t>acuan</a:t>
+                        <a:t>−0,07</a:t>
                       </a:r>
                       <a:endParaRPr lang="en-US" sz="1300" dirty="0">
                         <a:latin typeface="Calibri" charset="0"/>
@@ -21565,7 +21565,7 @@
                           <a:ea typeface="Calibri" pitchFamily="34" charset="-122"/>
                           <a:cs typeface="Calibri" pitchFamily="34" charset="-120"/>
                         </a:rPr>
-                        <a:t>–</a:t>
+                        <a:t>0,802</a:t>
                       </a:r>
                       <a:endParaRPr lang="en-US" sz="1300" dirty="0">
                         <a:latin typeface="Calibri" charset="0"/>
@@ -21839,7 +21839,7 @@
                           <a:ea typeface="Calibri" pitchFamily="34" charset="-122"/>
                           <a:cs typeface="Calibri" pitchFamily="34" charset="-120"/>
                         </a:rPr>
-                        <a:t>−0,21</a:t>
+                        <a:t>acuan</a:t>
                       </a:r>
                       <a:endParaRPr lang="en-US" sz="1300" dirty="0">
                         <a:latin typeface="Calibri" charset="0"/>
@@ -21907,7 +21907,7 @@
                           <a:ea typeface="Calibri" pitchFamily="34" charset="-122"/>
                           <a:cs typeface="Calibri" pitchFamily="34" charset="-120"/>
                         </a:rPr>
-                        <a:t>0,745</a:t>
+                        <a:t>–</a:t>
                       </a:r>
                       <a:endParaRPr lang="en-US" sz="1300" dirty="0">
                         <a:latin typeface="Calibri" charset="0"/>
@@ -22181,7 +22181,7 @@
                           <a:ea typeface="Calibri" pitchFamily="34" charset="-122"/>
                           <a:cs typeface="Calibri" pitchFamily="34" charset="-120"/>
                         </a:rPr>
-                        <a:t>−0,77</a:t>
+                        <a:t>−2,66</a:t>
                       </a:r>
                       <a:endParaRPr lang="en-US" sz="1300" dirty="0">
                         <a:latin typeface="Calibri" charset="0"/>
@@ -22249,7 +22249,7 @@
                           <a:ea typeface="Calibri" pitchFamily="34" charset="-122"/>
                           <a:cs typeface="Calibri" pitchFamily="34" charset="-120"/>
                         </a:rPr>
-                        <a:t>0,616</a:t>
+                        <a:t>0,601</a:t>
                       </a:r>
                       <a:endParaRPr lang="en-US" sz="1300" dirty="0">
                         <a:latin typeface="Calibri" charset="0"/>
@@ -22515,7 +22515,7 @@
                 <a:ea typeface="Calibri" pitchFamily="34" charset="-122"/>
                 <a:cs typeface="Calibri" pitchFamily="34" charset="-120"/>
               </a:rPr>
-              <a:t>Hanya baseline yang nyata lebih rendah (p = 0,042). Selisih antaralgoritma belum signifikan → perlu lebih banyak akun.</a:t>
+              <a:t>Hanya baseline yang nyata lebih rendah (p = 0,003). Selisih antaralgoritma belum signifikan → perlu lebih banyak akun.</a:t>
             </a:r>
             <a:endParaRPr lang="en-US" sz="1400" dirty="0"/>
           </a:p>
@@ -22901,7 +22901,7 @@
                 <a:ea typeface="Calibri" pitchFamily="34" charset="-122"/>
                 <a:cs typeface="Calibri" pitchFamily="34" charset="-120"/>
               </a:rPr>
-              <a:t>Hampir 0% sampai pull ke-73, lalu 14% (pull 74–78) dan 38% (79–90). Hampir sama dengan model.</a:t>
+              <a:t>0,7% sampai pull ke-73, lalu 14% (74–78) dan 38% (79–90). Mendekati model.</a:t>
             </a:r>
             <a:endParaRPr lang="en-US" sz="1400" dirty="0"/>
           </a:p>
@@ -23009,7 +23009,7 @@
                 <a:ea typeface="Calibri" pitchFamily="34" charset="-122"/>
                 <a:cs typeface="Calibri" pitchFamily="34" charset="-120"/>
               </a:rPr>
-              <a:t>Decision Tree dari data asli saja memisah di pity ±66 (Agent) / ±59 (W-Engine), ±10 pull sebelum soft pity.</a:t>
+              <a:t>Decision Tree dari data asli saja memisah di pity ±65 (Agent) / ±58 (W-Engine), ±10 pull sebelum soft pity.</a:t>
             </a:r>
             <a:endParaRPr lang="en-US" sz="1400" dirty="0"/>
           </a:p>
@@ -23048,7 +23048,7 @@
                 <a:ea typeface="Calibri" pitchFamily="34" charset="-122"/>
                 <a:cs typeface="Calibri" pitchFamily="34" charset="-120"/>
               </a:rPr>
-              <a:t>W-Engine: 4 dari 11 pull mulai pull ke-65 menghasilkan S (36%), lebih tinggi dari model, tetapi datanya masih sedikit.</a:t>
+              <a:t>W-Engine: 4 dari 11 pull mulai pull ke-65 menghasilkan S (36%), lebih tinggi dari model (12%), tetapi datanya masih sedikit.</a:t>
             </a:r>
             <a:endParaRPr lang="en-US" sz="1400" dirty="0"/>
           </a:p>
@@ -24544,7 +24544,7 @@
                 <a:ea typeface="Calibri" pitchFamily="34" charset="-122"/>
                 <a:cs typeface="Calibri" pitchFamily="34" charset="-120"/>
               </a:rPr>
-              <a:t>Pohon (DT, RF, XGBoost) &amp; KNN setara terbaik: ±91% simulasi, ±93% data asli. NB &amp; LR nyata lebih rendah. Di data asli saja, selisihnya belum signifikan.</a:t>
+              <a:t>Pohon (DT, RF, XGBoost) &amp; KNN setara terbaik: ±91% simulasi, ±92% data asli. NB &amp; LR nyata lebih rendah. Di data asli saja, selisihnya belum signifikan.</a:t>
             </a:r>
             <a:endParaRPr lang="en-US" sz="1400" dirty="0"/>
           </a:p>

</xml_diff>

<commit_message>
Pakai nama lengkap anggota di semua dokumen
Nama lengkap dipakai di proposal, laporan, kedua slide, README, LAPORAN.md,
LICENSE, dan NOTICE. Kolom nama di sampul, tabel anggota, dan slide tim
dilebarkan supaya nama tidak terpotong, dan kolom kegiatan di jadwal
dilebarkan supaya setiap kegiatan muat satu baris.
</commit_message>
<xml_diff>
--- a/docs/tugas/UAS_Slide_Kelompok6_A11.4502.pptx
+++ b/docs/tugas/UAS_Slide_Kelompok6_A11.4502.pptx
@@ -17342,9 +17342,9 @@
             <a:tbl>
               <a:tblPr/>
               <a:tblGrid>
-                <a:gridCol w="2194560"/>
-                <a:gridCol w="3108960"/>
-                <a:gridCol w="5760720"/>
+                <a:gridCol w="2011680"/>
+                <a:gridCol w="3383280"/>
+                <a:gridCol w="5669280"/>
               </a:tblGrid>
               <a:tr h="566928">
                 <a:tc>
@@ -17844,7 +17844,7 @@
                           <a:ea typeface="Calibri" pitchFamily="34" charset="-122"/>
                           <a:cs typeface="Calibri" pitchFamily="34" charset="-120"/>
                         </a:rPr>
-                        <a:t>Dafi Hauzan A.H</a:t>
+                        <a:t>Dafi Hauzan Atsillah Hoenarko</a:t>
                       </a:r>
                       <a:endParaRPr lang="en-US" sz="1500" dirty="0">
                         <a:latin typeface="Calibri" charset="0"/>
@@ -18050,7 +18050,7 @@
                           <a:ea typeface="Calibri" pitchFamily="34" charset="-122"/>
                           <a:cs typeface="Calibri" pitchFamily="34" charset="-120"/>
                         </a:rPr>
-                        <a:t>Gastiadirrijal Rafi M</a:t>
+                        <a:t>Gastiadirrijal Rafi Maulana</a:t>
                       </a:r>
                       <a:endParaRPr lang="en-US" sz="1500" dirty="0">
                         <a:latin typeface="Calibri" charset="0"/>
@@ -18256,7 +18256,7 @@
                           <a:ea typeface="Calibri" pitchFamily="34" charset="-122"/>
                           <a:cs typeface="Calibri" pitchFamily="34" charset="-120"/>
                         </a:rPr>
-                        <a:t>Zabrina Miftah Z</a:t>
+                        <a:t>Zabrina Miftah Zulaikha</a:t>
                       </a:r>
                       <a:endParaRPr lang="en-US" sz="1500" dirty="0">
                         <a:latin typeface="Calibri" charset="0"/>

</xml_diff>